<commit_message>
Clarify AI engineering responsibility model
</commit_message>
<xml_diff>
--- a/training/06_Training_Presentation.pptx
+++ b/training/06_Training_Presentation.pptx
@@ -2,21 +2,21 @@
 <file path=ppt/presentation.xml><?xml version="1.0" encoding="utf-8"?>
 <p:presentation xmlns:p="http://schemas.openxmlformats.org/presentationml/2006/main">
   <p:sldMasterIdLst>
-    <p:sldMasterId xmlns:r="http://schemas.openxmlformats.org/officeDocument/2006/relationships" id="2147483648" r:id="Rcde2ca7c294246a4"/>
+    <p:sldMasterId xmlns:r="http://schemas.openxmlformats.org/officeDocument/2006/relationships" id="2147483648" r:id="R77f98b44952e4941"/>
   </p:sldMasterIdLst>
   <p:notesMasterIdLst>
-    <p:notesMasterId xmlns:r="http://schemas.openxmlformats.org/officeDocument/2006/relationships" r:id="R78f3b823a3c540db"/>
+    <p:notesMasterId xmlns:r="http://schemas.openxmlformats.org/officeDocument/2006/relationships" r:id="R5907cea19c8b4f46"/>
   </p:notesMasterIdLst>
   <p:sldIdLst>
-    <p:sldId xmlns:r="http://schemas.openxmlformats.org/officeDocument/2006/relationships" id="256" r:id="R491ee0cc2bd74e6c"/>
-    <p:sldId xmlns:r="http://schemas.openxmlformats.org/officeDocument/2006/relationships" id="257" r:id="R76a484f212744845"/>
-    <p:sldId xmlns:r="http://schemas.openxmlformats.org/officeDocument/2006/relationships" id="258" r:id="R1b4b6c60443a40cd"/>
-    <p:sldId xmlns:r="http://schemas.openxmlformats.org/officeDocument/2006/relationships" id="259" r:id="Rc5ecd70442784c3a"/>
-    <p:sldId xmlns:r="http://schemas.openxmlformats.org/officeDocument/2006/relationships" id="260" r:id="Rfd62d1778ef743d8"/>
-    <p:sldId xmlns:r="http://schemas.openxmlformats.org/officeDocument/2006/relationships" id="261" r:id="R3847ffcd973c4c75"/>
-    <p:sldId xmlns:r="http://schemas.openxmlformats.org/officeDocument/2006/relationships" id="262" r:id="R664700dcc77f4ccd"/>
-    <p:sldId xmlns:r="http://schemas.openxmlformats.org/officeDocument/2006/relationships" id="263" r:id="R4704fa9bb9424322"/>
-    <p:sldId xmlns:r="http://schemas.openxmlformats.org/officeDocument/2006/relationships" id="264" r:id="R667035ae0ff14abb"/>
+    <p:sldId xmlns:r="http://schemas.openxmlformats.org/officeDocument/2006/relationships" id="256" r:id="R6c6808a2cb1f4ed9"/>
+    <p:sldId xmlns:r="http://schemas.openxmlformats.org/officeDocument/2006/relationships" id="257" r:id="Rb8a7c926bfaa4b88"/>
+    <p:sldId xmlns:r="http://schemas.openxmlformats.org/officeDocument/2006/relationships" id="258" r:id="R87bd66036b4243d6"/>
+    <p:sldId xmlns:r="http://schemas.openxmlformats.org/officeDocument/2006/relationships" id="259" r:id="R184d36e8f57a4088"/>
+    <p:sldId xmlns:r="http://schemas.openxmlformats.org/officeDocument/2006/relationships" id="260" r:id="R5d4c4f4f3d1d44af"/>
+    <p:sldId xmlns:r="http://schemas.openxmlformats.org/officeDocument/2006/relationships" id="261" r:id="R6ff906b268ba44f9"/>
+    <p:sldId xmlns:r="http://schemas.openxmlformats.org/officeDocument/2006/relationships" id="262" r:id="R7ccb450144984281"/>
+    <p:sldId xmlns:r="http://schemas.openxmlformats.org/officeDocument/2006/relationships" id="263" r:id="Rf583792f217142fa"/>
+    <p:sldId xmlns:r="http://schemas.openxmlformats.org/officeDocument/2006/relationships" id="264" r:id="Re1591e8753f54fc9"/>
   </p:sldIdLst>
   <p:sldSz cx="12192000" cy="6858000"/>
   <p:notesSz cx="6858000" cy="9144000"/>
@@ -1137,7 +1137,7 @@
   </p:cSld>
   <p:clrMap bg1="lt1" tx1="dk1" bg2="lt2" tx2="dk2" accent1="accent1" accent2="accent2" accent3="accent3" accent4="accent4" accent5="accent5" accent6="accent6" hlink="hlink" folHlink="folHlink"/>
   <p:sldLayoutIdLst>
-    <p:sldLayoutId xmlns:r="http://schemas.openxmlformats.org/officeDocument/2006/relationships" id="2147483649" r:id="R2197c2ce00384461"/>
+    <p:sldLayoutId xmlns:r="http://schemas.openxmlformats.org/officeDocument/2006/relationships" id="2147483649" r:id="Re7680494be374372"/>
   </p:sldLayoutIdLst>
   <p:txStyles>
     <p:titleStyle>
@@ -2028,7 +2028,7 @@
                 <a:ea typeface="Noto Sans TC"/>
                 <a:cs typeface="Noto Sans TC"/>
               </a:rPr>
-              <a:t>v1.11 Baseline Candidate</a:t>
+              <a:t>v1.14 Baseline Candidate</a:t>
             </a:r>
           </a:p>
         </p:txBody>
@@ -2123,7 +2123,7 @@
       </p:sp>
       <p:cxnSp>
         <p:nvCxnSpPr>
-          <p:cNvPr id="225" name=""/>
+          <p:cNvPr id="256" name=""/>
           <p:cNvCxnSpPr/>
           <p:nvPr/>
         </p:nvCxnSpPr>
@@ -3224,14 +3224,14 @@
       </p:sp>
       <p:pic>
         <p:nvPicPr>
-          <p:cNvPr id="247" name=""/>
+          <p:cNvPr id="278" name=""/>
           <p:cNvPicPr>
             <a:picLocks xmlns:a="http://schemas.openxmlformats.org/drawingml/2006/main" noChangeAspect="1"/>
           </p:cNvPicPr>
           <p:nvPr/>
         </p:nvPicPr>
         <p:blipFill>
-          <a:blip xmlns:r="http://schemas.openxmlformats.org/officeDocument/2006/relationships" xmlns:a="http://schemas.openxmlformats.org/drawingml/2006/main" r:embed="R87e1422cc8de4a13"/>
+          <a:blip xmlns:r="http://schemas.openxmlformats.org/officeDocument/2006/relationships" xmlns:a="http://schemas.openxmlformats.org/drawingml/2006/main" r:embed="R80c38a346eb44d8d"/>
           <a:stretch xmlns:a="http://schemas.openxmlformats.org/drawingml/2006/main"/>
         </p:blipFill>
         <p:spPr>
@@ -3246,14 +3246,14 @@
       </p:pic>
       <p:pic>
         <p:nvPicPr>
-          <p:cNvPr id="248" name=""/>
+          <p:cNvPr id="279" name=""/>
           <p:cNvPicPr>
             <a:picLocks xmlns:a="http://schemas.openxmlformats.org/drawingml/2006/main" noChangeAspect="1"/>
           </p:cNvPicPr>
           <p:nvPr/>
         </p:nvPicPr>
         <p:blipFill>
-          <a:blip xmlns:r="http://schemas.openxmlformats.org/officeDocument/2006/relationships" xmlns:a="http://schemas.openxmlformats.org/drawingml/2006/main" r:embed="R4ce2865fe45148b2"/>
+          <a:blip xmlns:r="http://schemas.openxmlformats.org/officeDocument/2006/relationships" xmlns:a="http://schemas.openxmlformats.org/drawingml/2006/main" r:embed="R00fc49e325f84afa"/>
           <a:stretch xmlns:a="http://schemas.openxmlformats.org/drawingml/2006/main"/>
         </p:blipFill>
         <p:spPr>
@@ -3268,14 +3268,14 @@
       </p:pic>
       <p:pic>
         <p:nvPicPr>
-          <p:cNvPr id="249" name=""/>
+          <p:cNvPr id="280" name=""/>
           <p:cNvPicPr>
             <a:picLocks xmlns:a="http://schemas.openxmlformats.org/drawingml/2006/main" noChangeAspect="1"/>
           </p:cNvPicPr>
           <p:nvPr/>
         </p:nvPicPr>
         <p:blipFill>
-          <a:blip xmlns:r="http://schemas.openxmlformats.org/officeDocument/2006/relationships" xmlns:a="http://schemas.openxmlformats.org/drawingml/2006/main" r:embed="R2f39d7739c2046d8"/>
+          <a:blip xmlns:r="http://schemas.openxmlformats.org/officeDocument/2006/relationships" xmlns:a="http://schemas.openxmlformats.org/drawingml/2006/main" r:embed="R9cf41969f7ea493e"/>
           <a:stretch xmlns:a="http://schemas.openxmlformats.org/drawingml/2006/main"/>
         </p:blipFill>
         <p:spPr>
@@ -3288,6 +3288,65 @@
           </a:prstGeom>
         </p:spPr>
       </p:pic>
+      <p:sp>
+        <p:nvSpPr>
+          <p:cNvPr id="244" name="Human leverage note">
+            <a:extLst xmlns:a="http://schemas.openxmlformats.org/drawingml/2006/main">
+              <a:ext uri="{FF2B5EF4-FFF2-40B4-BE49-F238E27FC236}">
+                <a16:creationId xmlns:a16="http://schemas.microsoft.com/office/drawing/2014/main" id="{3BCC93CE-0A5A-48A8-AD30-34F73E3AFCD0}"/>
+              </a:ext>
+            </a:extLst>
+          </p:cNvPr>
+          <p:cNvSpPr>
+            <a:spLocks xmlns:a="http://schemas.openxmlformats.org/drawingml/2006/main" noGrp="1"/>
+          </p:cNvSpPr>
+          <p:nvPr/>
+        </p:nvSpPr>
+        <p:spPr>
+          <a:xfrm xmlns:a="http://schemas.openxmlformats.org/drawingml/2006/main">
+            <a:off x="400050" y="6057900"/>
+            <a:ext cx="10668000" cy="247650"/>
+          </a:xfrm>
+          <a:prstGeom xmlns:a="http://schemas.openxmlformats.org/drawingml/2006/main" prst="rect">
+            <a:avLst/>
+          </a:prstGeom>
+          <a:noFill xmlns:a="http://schemas.openxmlformats.org/drawingml/2006/main"/>
+          <a:ln xmlns:a="http://schemas.openxmlformats.org/drawingml/2006/main" w="0">
+            <a:noFill/>
+            <a:prstDash val="solid"/>
+          </a:ln>
+        </p:spPr>
+        <p:txBody>
+          <a:bodyPr xmlns:a="http://schemas.openxmlformats.org/drawingml/2006/main" wrap="square" lIns="0" tIns="0" rIns="0" bIns="0" anchor="ctr">
+            <a:noAutofit/>
+          </a:bodyPr>
+          <a:lstStyle xmlns:a="http://schemas.openxmlformats.org/drawingml/2006/main"/>
+          <a:p xmlns:a="http://schemas.openxmlformats.org/drawingml/2006/main">
+            <a:pPr algn="l">
+              <a:buNone/>
+              <a:defRPr sz="1125">
+                <a:solidFill>
+                  <a:srgbClr val="5C6570"/>
+                </a:solidFill>
+                <a:latin typeface="Noto Sans TC"/>
+                <a:ea typeface="Noto Sans TC"/>
+                <a:cs typeface="Noto Sans TC"/>
+              </a:defRPr>
+            </a:pPr>
+            <a:r>
+              <a:rPr sz="1125">
+                <a:solidFill>
+                  <a:srgbClr val="5C6570"/>
+                </a:solidFill>
+                <a:latin typeface="Noto Sans TC"/>
+                <a:ea typeface="Noto Sans TC"/>
+                <a:cs typeface="Noto Sans TC"/>
+              </a:rPr>
+              <a:t>AI 先自動化 coding；software engineering 的價值移向問題定義、設計判斷與責任。</a:t>
+            </a:r>
+          </a:p>
+        </p:txBody>
+      </p:sp>
     </p:spTree>
     <p:extLst>
       <p:ext uri="{BB962C8B-B14F-4D97-AF65-F5344CB8AC3E}">
@@ -3319,10 +3378,10 @@
       </p:grpSpPr>
       <p:sp>
         <p:nvSpPr>
-          <p:cNvPr id="594" name="">
-            <a:extLst xmlns:a="http://schemas.openxmlformats.org/drawingml/2006/main">
-              <a:ext uri="{FF2B5EF4-FFF2-40B4-BE49-F238E27FC236}">
-                <a16:creationId xmlns:a16="http://schemas.microsoft.com/office/drawing/2014/main" id="{82D91BCB-78E4-48DE-AB3E-3192C38596DE}"/>
+          <p:cNvPr id="479" name="">
+            <a:extLst xmlns:a="http://schemas.openxmlformats.org/drawingml/2006/main">
+              <a:ext uri="{FF2B5EF4-FFF2-40B4-BE49-F238E27FC236}">
+                <a16:creationId xmlns:a16="http://schemas.microsoft.com/office/drawing/2014/main" id="{93FE033D-66FD-48F9-BD5B-BB55095EECC8}"/>
               </a:ext>
             </a:extLst>
           </p:cNvPr>
@@ -3371,14 +3430,14 @@
                 <a:ea typeface="Noto Sans TC"/>
                 <a:cs typeface="Noto Sans TC"/>
               </a:rPr>
-              <a:t>這次建立的是：工程師每天能照著走的 AI Development Workflow</a:t>
+              <a:t>AI 執行愈多，工程責任愈需要清楚分工</a:t>
             </a:r>
           </a:p>
         </p:txBody>
       </p:sp>
       <p:cxnSp>
         <p:nvCxnSpPr>
-          <p:cNvPr id="626" name=""/>
+          <p:cNvPr id="655" name=""/>
           <p:cNvCxnSpPr/>
           <p:nvPr/>
         </p:nvCxnSpPr>
@@ -3403,7 +3462,7 @@
           <p:cNvPr id="3" name="">
             <a:extLst xmlns:a="http://schemas.openxmlformats.org/drawingml/2006/main">
               <a:ext uri="{FF2B5EF4-FFF2-40B4-BE49-F238E27FC236}">
-                <a16:creationId xmlns:a16="http://schemas.microsoft.com/office/drawing/2014/main" id="{5DE45FA3-39F3-4294-8E7A-93466669F7DA}"/>
+                <a16:creationId xmlns:a16="http://schemas.microsoft.com/office/drawing/2014/main" id="{572C6BFC-F52C-44C1-8405-957119A62B73}"/>
               </a:ext>
             </a:extLst>
           </p:cNvPr>
@@ -3462,19 +3521,50 @@
           <p:cNvPr id="4" name="">
             <a:extLst xmlns:a="http://schemas.openxmlformats.org/drawingml/2006/main">
               <a:ext uri="{FF2B5EF4-FFF2-40B4-BE49-F238E27FC236}">
-                <a16:creationId xmlns:a16="http://schemas.microsoft.com/office/drawing/2014/main" id="{9C56A29F-86B2-4BF0-8F7C-EEEBD0E7A271}"/>
-              </a:ext>
-            </a:extLst>
-          </p:cNvPr>
-          <p:cNvSpPr>
-            <a:spLocks xmlns:a="http://schemas.openxmlformats.org/drawingml/2006/main" noGrp="1"/>
-          </p:cNvSpPr>
-          <p:nvPr/>
-        </p:nvSpPr>
-        <p:spPr>
-          <a:xfrm xmlns:a="http://schemas.openxmlformats.org/drawingml/2006/main">
-            <a:off x="400050" y="1476375"/>
-            <a:ext cx="11391900" cy="685800"/>
+                <a16:creationId xmlns:a16="http://schemas.microsoft.com/office/drawing/2014/main" id="{2CA4A3A1-68E1-4207-AFA4-D8A95211607B}"/>
+              </a:ext>
+            </a:extLst>
+          </p:cNvPr>
+          <p:cNvSpPr>
+            <a:spLocks xmlns:a="http://schemas.openxmlformats.org/drawingml/2006/main" noGrp="1"/>
+          </p:cNvSpPr>
+          <p:nvPr/>
+        </p:nvSpPr>
+        <p:spPr>
+          <a:xfrm xmlns:a="http://schemas.openxmlformats.org/drawingml/2006/main">
+            <a:off x="400050" y="1619250"/>
+            <a:ext cx="3476625" cy="3905250"/>
+          </a:xfrm>
+          <a:prstGeom xmlns:a="http://schemas.openxmlformats.org/drawingml/2006/main" prst="rect">
+            <a:avLst/>
+          </a:prstGeom>
+          <a:solidFill xmlns:a="http://schemas.openxmlformats.org/drawingml/2006/main">
+            <a:srgbClr val="F1F2F3"/>
+          </a:solidFill>
+          <a:ln xmlns:a="http://schemas.openxmlformats.org/drawingml/2006/main" w="0">
+            <a:noFill/>
+            <a:prstDash val="solid"/>
+          </a:ln>
+        </p:spPr>
+      </p:sp>
+      <p:sp>
+        <p:nvSpPr>
+          <p:cNvPr id="5" name="">
+            <a:extLst xmlns:a="http://schemas.openxmlformats.org/drawingml/2006/main">
+              <a:ext uri="{FF2B5EF4-FFF2-40B4-BE49-F238E27FC236}">
+                <a16:creationId xmlns:a16="http://schemas.microsoft.com/office/drawing/2014/main" id="{63B5A021-266B-4788-9BBC-1258BEEF17F3}"/>
+              </a:ext>
+            </a:extLst>
+          </p:cNvPr>
+          <p:cNvSpPr>
+            <a:spLocks xmlns:a="http://schemas.openxmlformats.org/drawingml/2006/main" noGrp="1"/>
+          </p:cNvSpPr>
+          <p:nvPr/>
+        </p:nvSpPr>
+        <p:spPr>
+          <a:xfrm xmlns:a="http://schemas.openxmlformats.org/drawingml/2006/main">
+            <a:off x="400050" y="1619250"/>
+            <a:ext cx="3476625" cy="285750"/>
           </a:xfrm>
           <a:prstGeom xmlns:a="http://schemas.openxmlformats.org/drawingml/2006/main" prst="rect">
             <a:avLst/>
@@ -3490,22 +3580,81 @@
       </p:sp>
       <p:sp>
         <p:nvSpPr>
-          <p:cNvPr id="5" name="">
-            <a:extLst xmlns:a="http://schemas.openxmlformats.org/drawingml/2006/main">
-              <a:ext uri="{FF2B5EF4-FFF2-40B4-BE49-F238E27FC236}">
-                <a16:creationId xmlns:a16="http://schemas.microsoft.com/office/drawing/2014/main" id="{4604E358-0078-410C-9F81-89BCE3788D4E}"/>
-              </a:ext>
-            </a:extLst>
-          </p:cNvPr>
-          <p:cNvSpPr>
-            <a:spLocks xmlns:a="http://schemas.openxmlformats.org/drawingml/2006/main" noGrp="1"/>
-          </p:cNvSpPr>
-          <p:nvPr/>
-        </p:nvSpPr>
-        <p:spPr>
-          <a:xfrm xmlns:a="http://schemas.openxmlformats.org/drawingml/2006/main">
-            <a:off x="628650" y="1657350"/>
-            <a:ext cx="1476375" cy="285750"/>
+          <p:cNvPr id="6" name="">
+            <a:extLst xmlns:a="http://schemas.openxmlformats.org/drawingml/2006/main">
+              <a:ext uri="{FF2B5EF4-FFF2-40B4-BE49-F238E27FC236}">
+                <a16:creationId xmlns:a16="http://schemas.microsoft.com/office/drawing/2014/main" id="{47981578-E369-4BAE-B560-5A7E75603A74}"/>
+              </a:ext>
+            </a:extLst>
+          </p:cNvPr>
+          <p:cNvSpPr>
+            <a:spLocks xmlns:a="http://schemas.openxmlformats.org/drawingml/2006/main" noGrp="1"/>
+          </p:cNvSpPr>
+          <p:nvPr/>
+        </p:nvSpPr>
+        <p:spPr>
+          <a:xfrm xmlns:a="http://schemas.openxmlformats.org/drawingml/2006/main">
+            <a:off x="495300" y="1676400"/>
+            <a:ext cx="3286125" cy="171450"/>
+          </a:xfrm>
+          <a:prstGeom xmlns:a="http://schemas.openxmlformats.org/drawingml/2006/main" prst="rect">
+            <a:avLst/>
+          </a:prstGeom>
+          <a:noFill xmlns:a="http://schemas.openxmlformats.org/drawingml/2006/main"/>
+          <a:ln xmlns:a="http://schemas.openxmlformats.org/drawingml/2006/main" w="0">
+            <a:noFill/>
+            <a:prstDash val="solid"/>
+          </a:ln>
+        </p:spPr>
+        <p:txBody>
+          <a:bodyPr xmlns:a="http://schemas.openxmlformats.org/drawingml/2006/main" wrap="square" lIns="0" tIns="0" rIns="0" bIns="0" anchor="ctr">
+            <a:normAutofit fontScale="100000"/>
+          </a:bodyPr>
+          <a:lstStyle xmlns:a="http://schemas.openxmlformats.org/drawingml/2006/main"/>
+          <a:p xmlns:a="http://schemas.openxmlformats.org/drawingml/2006/main">
+            <a:pPr algn="l">
+              <a:buNone/>
+              <a:defRPr sz="975" b="1">
+                <a:solidFill>
+                  <a:srgbClr val="FFFFFF"/>
+                </a:solidFill>
+                <a:latin typeface="Noto Sans TC"/>
+                <a:ea typeface="Noto Sans TC"/>
+                <a:cs typeface="Noto Sans TC"/>
+              </a:defRPr>
+            </a:pPr>
+            <a:r>
+              <a:rPr sz="975" b="1">
+                <a:solidFill>
+                  <a:srgbClr val="FFFFFF"/>
+                </a:solidFill>
+                <a:latin typeface="Noto Sans TC"/>
+                <a:ea typeface="Noto Sans TC"/>
+                <a:cs typeface="Noto Sans TC"/>
+              </a:rPr>
+              <a:t>HUMAN JUDGMENT</a:t>
+            </a:r>
+          </a:p>
+        </p:txBody>
+      </p:sp>
+      <p:sp>
+        <p:nvSpPr>
+          <p:cNvPr id="7" name="">
+            <a:extLst xmlns:a="http://schemas.openxmlformats.org/drawingml/2006/main">
+              <a:ext uri="{FF2B5EF4-FFF2-40B4-BE49-F238E27FC236}">
+                <a16:creationId xmlns:a16="http://schemas.microsoft.com/office/drawing/2014/main" id="{FAF7302B-A3EB-48CC-B6F5-DB990F5A9326}"/>
+              </a:ext>
+            </a:extLst>
+          </p:cNvPr>
+          <p:cNvSpPr>
+            <a:spLocks xmlns:a="http://schemas.openxmlformats.org/drawingml/2006/main" noGrp="1"/>
+          </p:cNvSpPr>
+          <p:nvPr/>
+        </p:nvSpPr>
+        <p:spPr>
+          <a:xfrm xmlns:a="http://schemas.openxmlformats.org/drawingml/2006/main">
+            <a:off x="628650" y="2152650"/>
+            <a:ext cx="3000375" cy="304800"/>
           </a:xfrm>
           <a:prstGeom xmlns:a="http://schemas.openxmlformats.org/drawingml/2006/main" prst="rect">
             <a:avLst/>
@@ -3524,47 +3673,47 @@
           <a:p xmlns:a="http://schemas.openxmlformats.org/drawingml/2006/main">
             <a:pPr algn="l">
               <a:buNone/>
-              <a:defRPr sz="1350" b="1">
-                <a:solidFill>
-                  <a:srgbClr val="6DCBF4"/>
-                </a:solidFill>
-                <a:latin typeface="Noto Sans TC"/>
-                <a:ea typeface="Noto Sans TC"/>
-                <a:cs typeface="Noto Sans TC"/>
-              </a:defRPr>
-            </a:pPr>
-            <a:r>
-              <a:rPr sz="1350" b="1">
-                <a:solidFill>
-                  <a:srgbClr val="6DCBF4"/>
-                </a:solidFill>
-                <a:latin typeface="Noto Sans TC"/>
-                <a:ea typeface="Noto Sans TC"/>
-                <a:cs typeface="Noto Sans TC"/>
-              </a:rPr>
-              <a:t>持久核心</a:t>
-            </a:r>
-          </a:p>
-        </p:txBody>
-      </p:sp>
-      <p:sp>
-        <p:nvSpPr>
-          <p:cNvPr id="6" name="">
-            <a:extLst xmlns:a="http://schemas.openxmlformats.org/drawingml/2006/main">
-              <a:ext uri="{FF2B5EF4-FFF2-40B4-BE49-F238E27FC236}">
-                <a16:creationId xmlns:a16="http://schemas.microsoft.com/office/drawing/2014/main" id="{2CA7B60E-7A92-4B04-AB0E-2E2019BF2DC2}"/>
-              </a:ext>
-            </a:extLst>
-          </p:cNvPr>
-          <p:cNvSpPr>
-            <a:spLocks xmlns:a="http://schemas.openxmlformats.org/drawingml/2006/main" noGrp="1"/>
-          </p:cNvSpPr>
-          <p:nvPr/>
-        </p:nvSpPr>
-        <p:spPr>
-          <a:xfrm xmlns:a="http://schemas.openxmlformats.org/drawingml/2006/main">
-            <a:off x="2238375" y="1657350"/>
-            <a:ext cx="9048750" cy="285750"/>
+              <a:defRPr sz="1725" b="1">
+                <a:solidFill>
+                  <a:srgbClr val="111111"/>
+                </a:solidFill>
+                <a:latin typeface="Noto Sans TC"/>
+                <a:ea typeface="Noto Sans TC"/>
+                <a:cs typeface="Noto Sans TC"/>
+              </a:defRPr>
+            </a:pPr>
+            <a:r>
+              <a:rPr sz="1725" b="1">
+                <a:solidFill>
+                  <a:srgbClr val="111111"/>
+                </a:solidFill>
+                <a:latin typeface="Noto Sans TC"/>
+                <a:ea typeface="Noto Sans TC"/>
+                <a:cs typeface="Noto Sans TC"/>
+              </a:rPr>
+              <a:t>人決定方向</a:t>
+            </a:r>
+          </a:p>
+        </p:txBody>
+      </p:sp>
+      <p:sp>
+        <p:nvSpPr>
+          <p:cNvPr id="8" name="">
+            <a:extLst xmlns:a="http://schemas.openxmlformats.org/drawingml/2006/main">
+              <a:ext uri="{FF2B5EF4-FFF2-40B4-BE49-F238E27FC236}">
+                <a16:creationId xmlns:a16="http://schemas.microsoft.com/office/drawing/2014/main" id="{E8F4F60F-AB8B-4625-B263-C6722302A3DF}"/>
+              </a:ext>
+            </a:extLst>
+          </p:cNvPr>
+          <p:cNvSpPr>
+            <a:spLocks xmlns:a="http://schemas.openxmlformats.org/drawingml/2006/main" noGrp="1"/>
+          </p:cNvSpPr>
+          <p:nvPr/>
+        </p:nvSpPr>
+        <p:spPr>
+          <a:xfrm xmlns:a="http://schemas.openxmlformats.org/drawingml/2006/main">
+            <a:off x="628650" y="2714625"/>
+            <a:ext cx="3000375" cy="1809750"/>
           </a:xfrm>
           <a:prstGeom xmlns:a="http://schemas.openxmlformats.org/drawingml/2006/main" prst="rect">
             <a:avLst/>
@@ -3583,135 +3732,710 @@
           <a:p xmlns:a="http://schemas.openxmlformats.org/drawingml/2006/main">
             <a:pPr algn="l">
               <a:buNone/>
-              <a:defRPr sz="1650" b="1">
-                <a:solidFill>
-                  <a:srgbClr val="FFFFFF"/>
-                </a:solidFill>
-                <a:latin typeface="Noto Sans TC"/>
-                <a:ea typeface="Noto Sans TC"/>
-                <a:cs typeface="Noto Sans TC"/>
-              </a:defRPr>
-            </a:pPr>
-            <a:r>
-              <a:rPr sz="1650" b="1">
-                <a:solidFill>
-                  <a:srgbClr val="FFFFFF"/>
-                </a:solidFill>
-                <a:latin typeface="Noto Sans TC"/>
-                <a:ea typeface="Noto Sans TC"/>
-                <a:cs typeface="Noto Sans TC"/>
-              </a:rPr>
-              <a:t>AI models 會一直變強 · Engineering workflow / ownership / evidence 必須持久</a:t>
+              <a:defRPr sz="1275" b="0">
+                <a:solidFill>
+                  <a:srgbClr val="111111"/>
+                </a:solidFill>
+                <a:latin typeface="Noto Sans TC"/>
+                <a:ea typeface="Noto Sans TC"/>
+                <a:cs typeface="Noto Sans TC"/>
+              </a:defRPr>
+            </a:pPr>
+            <a:r>
+              <a:rPr sz="1275" b="0">
+                <a:solidFill>
+                  <a:srgbClr val="111111"/>
+                </a:solidFill>
+                <a:latin typeface="Noto Sans TC"/>
+                <a:ea typeface="Noto Sans TC"/>
+                <a:cs typeface="Noto Sans TC"/>
+              </a:rPr>
+              <a:t>定義問題與 outcome</a:t>
+            </a:r>
+          </a:p>
+          <a:p xmlns:a="http://schemas.openxmlformats.org/drawingml/2006/main">
+            <a:pPr algn="l">
+              <a:buNone/>
+              <a:defRPr sz="1275" b="0">
+                <a:solidFill>
+                  <a:srgbClr val="111111"/>
+                </a:solidFill>
+                <a:latin typeface="Noto Sans TC"/>
+                <a:ea typeface="Noto Sans TC"/>
+                <a:cs typeface="Noto Sans TC"/>
+              </a:defRPr>
+            </a:pPr>
+            <a:r>
+              <a:rPr sz="1275" b="0">
+                <a:solidFill>
+                  <a:srgbClr val="111111"/>
+                </a:solidFill>
+                <a:latin typeface="Noto Sans TC"/>
+                <a:ea typeface="Noto Sans TC"/>
+                <a:cs typeface="Noto Sans TC"/>
+              </a:rPr>
+              <a:t>做 design trade-off</a:t>
+            </a:r>
+          </a:p>
+          <a:p xmlns:a="http://schemas.openxmlformats.org/drawingml/2006/main">
+            <a:pPr algn="l">
+              <a:buNone/>
+              <a:defRPr sz="1275" b="0">
+                <a:solidFill>
+                  <a:srgbClr val="111111"/>
+                </a:solidFill>
+                <a:latin typeface="Noto Sans TC"/>
+                <a:ea typeface="Noto Sans TC"/>
+                <a:cs typeface="Noto Sans TC"/>
+              </a:defRPr>
+            </a:pPr>
+            <a:r>
+              <a:rPr sz="1275" b="0">
+                <a:solidFill>
+                  <a:srgbClr val="111111"/>
+                </a:solidFill>
+                <a:latin typeface="Noto Sans TC"/>
+                <a:ea typeface="Noto Sans TC"/>
+                <a:cs typeface="Noto Sans TC"/>
+              </a:rPr>
+              <a:t>決定 scope / risk / approval</a:t>
+            </a:r>
+          </a:p>
+          <a:p xmlns:a="http://schemas.openxmlformats.org/drawingml/2006/main">
+            <a:pPr algn="l">
+              <a:buNone/>
+              <a:defRPr sz="1275" b="0">
+                <a:solidFill>
+                  <a:srgbClr val="111111"/>
+                </a:solidFill>
+                <a:latin typeface="Noto Sans TC"/>
+                <a:ea typeface="Noto Sans TC"/>
+                <a:cs typeface="Noto Sans TC"/>
+              </a:defRPr>
+            </a:pPr>
+            <a:r>
+              <a:rPr sz="1275" b="0">
+                <a:solidFill>
+                  <a:srgbClr val="111111"/>
+                </a:solidFill>
+                <a:latin typeface="Noto Sans TC"/>
+                <a:ea typeface="Noto Sans TC"/>
+                <a:cs typeface="Noto Sans TC"/>
+              </a:rPr>
+              <a:t>對結果負責</a:t>
             </a:r>
           </a:p>
         </p:txBody>
       </p:sp>
       <p:cxnSp>
         <p:nvCxnSpPr>
-          <p:cNvPr id="631" name=""/>
+          <p:cNvPr id="662" name=""/>
           <p:cNvCxnSpPr/>
           <p:nvPr/>
         </p:nvCxnSpPr>
         <p:spPr>
           <a:xfrm xmlns:a="http://schemas.openxmlformats.org/drawingml/2006/main">
-            <a:off x="2190750" y="3333750"/>
-            <a:ext cx="400050" cy="0"/>
+            <a:off x="628650" y="4762500"/>
+            <a:ext cx="3019425" cy="0"/>
           </a:xfrm>
           <a:prstGeom xmlns:a="http://schemas.openxmlformats.org/drawingml/2006/main" prst="straightConnector1">
             <a:avLst/>
           </a:prstGeom>
-          <a:ln xmlns:a="http://schemas.openxmlformats.org/drawingml/2006/main" w="19050">
+          <a:ln xmlns:a="http://schemas.openxmlformats.org/drawingml/2006/main" w="9525">
             <a:solidFill>
-              <a:srgbClr val="2478E5"/>
+              <a:srgbClr val="B8BCC4"/>
             </a:solidFill>
             <a:prstDash val="solid"/>
           </a:ln>
         </p:spPr>
       </p:cxnSp>
+      <p:sp>
+        <p:nvSpPr>
+          <p:cNvPr id="10" name="">
+            <a:extLst xmlns:a="http://schemas.openxmlformats.org/drawingml/2006/main">
+              <a:ext uri="{FF2B5EF4-FFF2-40B4-BE49-F238E27FC236}">
+                <a16:creationId xmlns:a16="http://schemas.microsoft.com/office/drawing/2014/main" id="{3D5A33C3-2CCF-4A54-81FF-0EB401E4C8E6}"/>
+              </a:ext>
+            </a:extLst>
+          </p:cNvPr>
+          <p:cNvSpPr>
+            <a:spLocks xmlns:a="http://schemas.openxmlformats.org/drawingml/2006/main" noGrp="1"/>
+          </p:cNvSpPr>
+          <p:nvPr/>
+        </p:nvSpPr>
+        <p:spPr>
+          <a:xfrm xmlns:a="http://schemas.openxmlformats.org/drawingml/2006/main">
+            <a:off x="628650" y="4962525"/>
+            <a:ext cx="952500" cy="209550"/>
+          </a:xfrm>
+          <a:prstGeom xmlns:a="http://schemas.openxmlformats.org/drawingml/2006/main" prst="rect">
+            <a:avLst/>
+          </a:prstGeom>
+          <a:noFill xmlns:a="http://schemas.openxmlformats.org/drawingml/2006/main"/>
+          <a:ln xmlns:a="http://schemas.openxmlformats.org/drawingml/2006/main" w="0">
+            <a:noFill/>
+            <a:prstDash val="solid"/>
+          </a:ln>
+        </p:spPr>
+        <p:txBody>
+          <a:bodyPr xmlns:a="http://schemas.openxmlformats.org/drawingml/2006/main" wrap="square" lIns="0" tIns="0" rIns="0" bIns="0" anchor="t">
+            <a:normAutofit fontScale="100000"/>
+          </a:bodyPr>
+          <a:lstStyle xmlns:a="http://schemas.openxmlformats.org/drawingml/2006/main"/>
+          <a:p xmlns:a="http://schemas.openxmlformats.org/drawingml/2006/main">
+            <a:pPr algn="l">
+              <a:buNone/>
+              <a:defRPr sz="975" b="1">
+                <a:solidFill>
+                  <a:srgbClr val="2478E5"/>
+                </a:solidFill>
+                <a:latin typeface="Noto Sans TC"/>
+                <a:ea typeface="Noto Sans TC"/>
+                <a:cs typeface="Noto Sans TC"/>
+              </a:defRPr>
+            </a:pPr>
+            <a:r>
+              <a:rPr sz="975" b="1">
+                <a:solidFill>
+                  <a:srgbClr val="2478E5"/>
+                </a:solidFill>
+                <a:latin typeface="Noto Sans TC"/>
+                <a:ea typeface="Noto Sans TC"/>
+                <a:cs typeface="Noto Sans TC"/>
+              </a:rPr>
+              <a:t>OWNS</a:t>
+            </a:r>
+          </a:p>
+        </p:txBody>
+      </p:sp>
+      <p:sp>
+        <p:nvSpPr>
+          <p:cNvPr id="11" name="">
+            <a:extLst xmlns:a="http://schemas.openxmlformats.org/drawingml/2006/main">
+              <a:ext uri="{FF2B5EF4-FFF2-40B4-BE49-F238E27FC236}">
+                <a16:creationId xmlns:a16="http://schemas.microsoft.com/office/drawing/2014/main" id="{5436842B-ABB5-4FF4-A1FD-E1CDCA1BC010}"/>
+              </a:ext>
+            </a:extLst>
+          </p:cNvPr>
+          <p:cNvSpPr>
+            <a:spLocks xmlns:a="http://schemas.openxmlformats.org/drawingml/2006/main" noGrp="1"/>
+          </p:cNvSpPr>
+          <p:nvPr/>
+        </p:nvSpPr>
+        <p:spPr>
+          <a:xfrm xmlns:a="http://schemas.openxmlformats.org/drawingml/2006/main">
+            <a:off x="628650" y="5219700"/>
+            <a:ext cx="3000375" cy="438150"/>
+          </a:xfrm>
+          <a:prstGeom xmlns:a="http://schemas.openxmlformats.org/drawingml/2006/main" prst="rect">
+            <a:avLst/>
+          </a:prstGeom>
+          <a:noFill xmlns:a="http://schemas.openxmlformats.org/drawingml/2006/main"/>
+          <a:ln xmlns:a="http://schemas.openxmlformats.org/drawingml/2006/main" w="0">
+            <a:noFill/>
+            <a:prstDash val="solid"/>
+          </a:ln>
+        </p:spPr>
+        <p:txBody>
+          <a:bodyPr xmlns:a="http://schemas.openxmlformats.org/drawingml/2006/main" wrap="square" lIns="0" tIns="0" rIns="0" bIns="0" anchor="t">
+            <a:normAutofit fontScale="100000"/>
+          </a:bodyPr>
+          <a:lstStyle xmlns:a="http://schemas.openxmlformats.org/drawingml/2006/main"/>
+          <a:p xmlns:a="http://schemas.openxmlformats.org/drawingml/2006/main">
+            <a:pPr algn="l">
+              <a:buNone/>
+              <a:defRPr sz="1125" b="1">
+                <a:solidFill>
+                  <a:srgbClr val="173B57"/>
+                </a:solidFill>
+                <a:latin typeface="Noto Sans TC"/>
+                <a:ea typeface="Noto Sans TC"/>
+                <a:cs typeface="Noto Sans TC"/>
+              </a:defRPr>
+            </a:pPr>
+            <a:r>
+              <a:rPr sz="1125" b="1">
+                <a:solidFill>
+                  <a:srgbClr val="173B57"/>
+                </a:solidFill>
+                <a:latin typeface="Noto Sans TC"/>
+                <a:ea typeface="Noto Sans TC"/>
+                <a:cs typeface="Noto Sans TC"/>
+              </a:rPr>
+              <a:t>Intent · design · decisions</a:t>
+            </a:r>
+          </a:p>
+        </p:txBody>
+      </p:sp>
+      <p:sp>
+        <p:nvSpPr>
+          <p:cNvPr id="12" name="">
+            <a:extLst xmlns:a="http://schemas.openxmlformats.org/drawingml/2006/main">
+              <a:ext uri="{FF2B5EF4-FFF2-40B4-BE49-F238E27FC236}">
+                <a16:creationId xmlns:a16="http://schemas.microsoft.com/office/drawing/2014/main" id="{95B77F80-F62D-40D2-92E2-ED78BB1387EE}"/>
+              </a:ext>
+            </a:extLst>
+          </p:cNvPr>
+          <p:cNvSpPr>
+            <a:spLocks xmlns:a="http://schemas.openxmlformats.org/drawingml/2006/main" noGrp="1"/>
+          </p:cNvSpPr>
+          <p:nvPr/>
+        </p:nvSpPr>
+        <p:spPr>
+          <a:xfrm xmlns:a="http://schemas.openxmlformats.org/drawingml/2006/main">
+            <a:off x="4276725" y="1619250"/>
+            <a:ext cx="3476625" cy="3905250"/>
+          </a:xfrm>
+          <a:prstGeom xmlns:a="http://schemas.openxmlformats.org/drawingml/2006/main" prst="rect">
+            <a:avLst/>
+          </a:prstGeom>
+          <a:solidFill xmlns:a="http://schemas.openxmlformats.org/drawingml/2006/main">
+            <a:srgbClr val="E7EAED"/>
+          </a:solidFill>
+          <a:ln xmlns:a="http://schemas.openxmlformats.org/drawingml/2006/main" w="0">
+            <a:noFill/>
+            <a:prstDash val="solid"/>
+          </a:ln>
+        </p:spPr>
+      </p:sp>
+      <p:sp>
+        <p:nvSpPr>
+          <p:cNvPr id="13" name="">
+            <a:extLst xmlns:a="http://schemas.openxmlformats.org/drawingml/2006/main">
+              <a:ext uri="{FF2B5EF4-FFF2-40B4-BE49-F238E27FC236}">
+                <a16:creationId xmlns:a16="http://schemas.microsoft.com/office/drawing/2014/main" id="{5BFCABB4-DC44-41E1-9F46-1D949A9B45CA}"/>
+              </a:ext>
+            </a:extLst>
+          </p:cNvPr>
+          <p:cNvSpPr>
+            <a:spLocks xmlns:a="http://schemas.openxmlformats.org/drawingml/2006/main" noGrp="1"/>
+          </p:cNvSpPr>
+          <p:nvPr/>
+        </p:nvSpPr>
+        <p:spPr>
+          <a:xfrm xmlns:a="http://schemas.openxmlformats.org/drawingml/2006/main">
+            <a:off x="4276725" y="1619250"/>
+            <a:ext cx="3476625" cy="285750"/>
+          </a:xfrm>
+          <a:prstGeom xmlns:a="http://schemas.openxmlformats.org/drawingml/2006/main" prst="rect">
+            <a:avLst/>
+          </a:prstGeom>
+          <a:solidFill xmlns:a="http://schemas.openxmlformats.org/drawingml/2006/main">
+            <a:srgbClr val="173B57"/>
+          </a:solidFill>
+          <a:ln xmlns:a="http://schemas.openxmlformats.org/drawingml/2006/main" w="0">
+            <a:noFill/>
+            <a:prstDash val="solid"/>
+          </a:ln>
+        </p:spPr>
+      </p:sp>
+      <p:sp>
+        <p:nvSpPr>
+          <p:cNvPr id="14" name="">
+            <a:extLst xmlns:a="http://schemas.openxmlformats.org/drawingml/2006/main">
+              <a:ext uri="{FF2B5EF4-FFF2-40B4-BE49-F238E27FC236}">
+                <a16:creationId xmlns:a16="http://schemas.microsoft.com/office/drawing/2014/main" id="{5792CCA2-507D-42DA-8734-85109C59457C}"/>
+              </a:ext>
+            </a:extLst>
+          </p:cNvPr>
+          <p:cNvSpPr>
+            <a:spLocks xmlns:a="http://schemas.openxmlformats.org/drawingml/2006/main" noGrp="1"/>
+          </p:cNvSpPr>
+          <p:nvPr/>
+        </p:nvSpPr>
+        <p:spPr>
+          <a:xfrm xmlns:a="http://schemas.openxmlformats.org/drawingml/2006/main">
+            <a:off x="4371975" y="1676400"/>
+            <a:ext cx="3286125" cy="171450"/>
+          </a:xfrm>
+          <a:prstGeom xmlns:a="http://schemas.openxmlformats.org/drawingml/2006/main" prst="rect">
+            <a:avLst/>
+          </a:prstGeom>
+          <a:noFill xmlns:a="http://schemas.openxmlformats.org/drawingml/2006/main"/>
+          <a:ln xmlns:a="http://schemas.openxmlformats.org/drawingml/2006/main" w="0">
+            <a:noFill/>
+            <a:prstDash val="solid"/>
+          </a:ln>
+        </p:spPr>
+        <p:txBody>
+          <a:bodyPr xmlns:a="http://schemas.openxmlformats.org/drawingml/2006/main" wrap="square" lIns="0" tIns="0" rIns="0" bIns="0" anchor="ctr">
+            <a:normAutofit fontScale="100000"/>
+          </a:bodyPr>
+          <a:lstStyle xmlns:a="http://schemas.openxmlformats.org/drawingml/2006/main"/>
+          <a:p xmlns:a="http://schemas.openxmlformats.org/drawingml/2006/main">
+            <a:pPr algn="l">
+              <a:buNone/>
+              <a:defRPr sz="975" b="1">
+                <a:solidFill>
+                  <a:srgbClr val="FFFFFF"/>
+                </a:solidFill>
+                <a:latin typeface="Noto Sans TC"/>
+                <a:ea typeface="Noto Sans TC"/>
+                <a:cs typeface="Noto Sans TC"/>
+              </a:defRPr>
+            </a:pPr>
+            <a:r>
+              <a:rPr sz="975" b="1">
+                <a:solidFill>
+                  <a:srgbClr val="FFFFFF"/>
+                </a:solidFill>
+                <a:latin typeface="Noto Sans TC"/>
+                <a:ea typeface="Noto Sans TC"/>
+                <a:cs typeface="Noto Sans TC"/>
+              </a:rPr>
+              <a:t>DURABLE WORKFLOW</a:t>
+            </a:r>
+          </a:p>
+        </p:txBody>
+      </p:sp>
+      <p:sp>
+        <p:nvSpPr>
+          <p:cNvPr id="15" name="">
+            <a:extLst xmlns:a="http://schemas.openxmlformats.org/drawingml/2006/main">
+              <a:ext uri="{FF2B5EF4-FFF2-40B4-BE49-F238E27FC236}">
+                <a16:creationId xmlns:a16="http://schemas.microsoft.com/office/drawing/2014/main" id="{2B86718B-9A73-4457-83A1-BB15F205710E}"/>
+              </a:ext>
+            </a:extLst>
+          </p:cNvPr>
+          <p:cNvSpPr>
+            <a:spLocks xmlns:a="http://schemas.openxmlformats.org/drawingml/2006/main" noGrp="1"/>
+          </p:cNvSpPr>
+          <p:nvPr/>
+        </p:nvSpPr>
+        <p:spPr>
+          <a:xfrm xmlns:a="http://schemas.openxmlformats.org/drawingml/2006/main">
+            <a:off x="4505325" y="2152650"/>
+            <a:ext cx="3000375" cy="304800"/>
+          </a:xfrm>
+          <a:prstGeom xmlns:a="http://schemas.openxmlformats.org/drawingml/2006/main" prst="rect">
+            <a:avLst/>
+          </a:prstGeom>
+          <a:noFill xmlns:a="http://schemas.openxmlformats.org/drawingml/2006/main"/>
+          <a:ln xmlns:a="http://schemas.openxmlformats.org/drawingml/2006/main" w="0">
+            <a:noFill/>
+            <a:prstDash val="solid"/>
+          </a:ln>
+        </p:spPr>
+        <p:txBody>
+          <a:bodyPr xmlns:a="http://schemas.openxmlformats.org/drawingml/2006/main" wrap="square" lIns="0" tIns="0" rIns="0" bIns="0" anchor="t">
+            <a:normAutofit fontScale="100000"/>
+          </a:bodyPr>
+          <a:lstStyle xmlns:a="http://schemas.openxmlformats.org/drawingml/2006/main"/>
+          <a:p xmlns:a="http://schemas.openxmlformats.org/drawingml/2006/main">
+            <a:pPr algn="l">
+              <a:buNone/>
+              <a:defRPr sz="1725" b="1">
+                <a:solidFill>
+                  <a:srgbClr val="111111"/>
+                </a:solidFill>
+                <a:latin typeface="Noto Sans TC"/>
+                <a:ea typeface="Noto Sans TC"/>
+                <a:cs typeface="Noto Sans TC"/>
+              </a:defRPr>
+            </a:pPr>
+            <a:r>
+              <a:rPr sz="1725" b="1">
+                <a:solidFill>
+                  <a:srgbClr val="111111"/>
+                </a:solidFill>
+                <a:latin typeface="Noto Sans TC"/>
+                <a:ea typeface="Noto Sans TC"/>
+                <a:cs typeface="Noto Sans TC"/>
+              </a:rPr>
+              <a:t>流程保存共識</a:t>
+            </a:r>
+          </a:p>
+        </p:txBody>
+      </p:sp>
+      <p:sp>
+        <p:nvSpPr>
+          <p:cNvPr id="16" name="">
+            <a:extLst xmlns:a="http://schemas.openxmlformats.org/drawingml/2006/main">
+              <a:ext uri="{FF2B5EF4-FFF2-40B4-BE49-F238E27FC236}">
+                <a16:creationId xmlns:a16="http://schemas.microsoft.com/office/drawing/2014/main" id="{0E1E8CF7-588E-4B22-B1D5-EBD03B72CF25}"/>
+              </a:ext>
+            </a:extLst>
+          </p:cNvPr>
+          <p:cNvSpPr>
+            <a:spLocks xmlns:a="http://schemas.openxmlformats.org/drawingml/2006/main" noGrp="1"/>
+          </p:cNvSpPr>
+          <p:nvPr/>
+        </p:nvSpPr>
+        <p:spPr>
+          <a:xfrm xmlns:a="http://schemas.openxmlformats.org/drawingml/2006/main">
+            <a:off x="4505325" y="2714625"/>
+            <a:ext cx="3000375" cy="1809750"/>
+          </a:xfrm>
+          <a:prstGeom xmlns:a="http://schemas.openxmlformats.org/drawingml/2006/main" prst="rect">
+            <a:avLst/>
+          </a:prstGeom>
+          <a:noFill xmlns:a="http://schemas.openxmlformats.org/drawingml/2006/main"/>
+          <a:ln xmlns:a="http://schemas.openxmlformats.org/drawingml/2006/main" w="0">
+            <a:noFill/>
+            <a:prstDash val="solid"/>
+          </a:ln>
+        </p:spPr>
+        <p:txBody>
+          <a:bodyPr xmlns:a="http://schemas.openxmlformats.org/drawingml/2006/main" wrap="square" lIns="0" tIns="0" rIns="0" bIns="0" anchor="t">
+            <a:normAutofit fontScale="100000"/>
+          </a:bodyPr>
+          <a:lstStyle xmlns:a="http://schemas.openxmlformats.org/drawingml/2006/main"/>
+          <a:p xmlns:a="http://schemas.openxmlformats.org/drawingml/2006/main">
+            <a:pPr algn="l">
+              <a:buNone/>
+              <a:defRPr sz="1275" b="0">
+                <a:solidFill>
+                  <a:srgbClr val="111111"/>
+                </a:solidFill>
+                <a:latin typeface="Noto Sans TC"/>
+                <a:ea typeface="Noto Sans TC"/>
+                <a:cs typeface="Noto Sans TC"/>
+              </a:defRPr>
+            </a:pPr>
+            <a:r>
+              <a:rPr sz="1275" b="0">
+                <a:solidFill>
+                  <a:srgbClr val="111111"/>
+                </a:solidFill>
+                <a:latin typeface="Noto Sans TC"/>
+                <a:ea typeface="Noto Sans TC"/>
+                <a:cs typeface="Noto Sans TC"/>
+              </a:rPr>
+              <a:t>Golden Flow：決定下一步</a:t>
+            </a:r>
+          </a:p>
+          <a:p xmlns:a="http://schemas.openxmlformats.org/drawingml/2006/main">
+            <a:pPr algn="l">
+              <a:buNone/>
+              <a:defRPr sz="1275" b="0">
+                <a:solidFill>
+                  <a:srgbClr val="111111"/>
+                </a:solidFill>
+                <a:latin typeface="Noto Sans TC"/>
+                <a:ea typeface="Noto Sans TC"/>
+                <a:cs typeface="Noto Sans TC"/>
+              </a:defRPr>
+            </a:pPr>
+            <a:r>
+              <a:rPr sz="1275" b="0">
+                <a:solidFill>
+                  <a:srgbClr val="111111"/>
+                </a:solidFill>
+                <a:latin typeface="Noto Sans TC"/>
+                <a:ea typeface="Noto Sans TC"/>
+                <a:cs typeface="Noto Sans TC"/>
+              </a:rPr>
+              <a:t>OpenSpec：durable agreement</a:t>
+            </a:r>
+          </a:p>
+          <a:p xmlns:a="http://schemas.openxmlformats.org/drawingml/2006/main">
+            <a:pPr algn="l">
+              <a:buNone/>
+              <a:defRPr sz="1275" b="0">
+                <a:solidFill>
+                  <a:srgbClr val="111111"/>
+                </a:solidFill>
+                <a:latin typeface="Noto Sans TC"/>
+                <a:ea typeface="Noto Sans TC"/>
+                <a:cs typeface="Noto Sans TC"/>
+              </a:defRPr>
+            </a:pPr>
+            <a:r>
+              <a:rPr sz="1275" b="0">
+                <a:solidFill>
+                  <a:srgbClr val="111111"/>
+                </a:solidFill>
+                <a:latin typeface="Noto Sans TC"/>
+                <a:ea typeface="Noto Sans TC"/>
+                <a:cs typeface="Noto Sans TC"/>
+              </a:rPr>
+              <a:t>Superpowers：engineering discipline</a:t>
+            </a:r>
+          </a:p>
+          <a:p xmlns:a="http://schemas.openxmlformats.org/drawingml/2006/main">
+            <a:pPr algn="l">
+              <a:buNone/>
+              <a:defRPr sz="1275" b="0">
+                <a:solidFill>
+                  <a:srgbClr val="111111"/>
+                </a:solidFill>
+                <a:latin typeface="Noto Sans TC"/>
+                <a:ea typeface="Noto Sans TC"/>
+                <a:cs typeface="Noto Sans TC"/>
+              </a:defRPr>
+            </a:pPr>
+            <a:r>
+              <a:rPr sz="1275" b="0">
+                <a:solidFill>
+                  <a:srgbClr val="111111"/>
+                </a:solidFill>
+                <a:latin typeface="Noto Sans TC"/>
+                <a:ea typeface="Noto Sans TC"/>
+                <a:cs typeface="Noto Sans TC"/>
+              </a:rPr>
+              <a:t>CI / PR：evidence trail</a:t>
+            </a:r>
+          </a:p>
+        </p:txBody>
+      </p:sp>
       <p:cxnSp>
         <p:nvCxnSpPr>
-          <p:cNvPr id="632" name=""/>
+          <p:cNvPr id="670" name=""/>
           <p:cNvCxnSpPr/>
           <p:nvPr/>
         </p:nvCxnSpPr>
         <p:spPr>
           <a:xfrm xmlns:a="http://schemas.openxmlformats.org/drawingml/2006/main">
-            <a:off x="4476750" y="3333750"/>
-            <a:ext cx="400050" cy="0"/>
+            <a:off x="4505325" y="4762500"/>
+            <a:ext cx="3019425" cy="0"/>
           </a:xfrm>
           <a:prstGeom xmlns:a="http://schemas.openxmlformats.org/drawingml/2006/main" prst="straightConnector1">
             <a:avLst/>
           </a:prstGeom>
-          <a:ln xmlns:a="http://schemas.openxmlformats.org/drawingml/2006/main" w="19050">
+          <a:ln xmlns:a="http://schemas.openxmlformats.org/drawingml/2006/main" w="9525">
             <a:solidFill>
-              <a:srgbClr val="2478E5"/>
+              <a:srgbClr val="B8BCC4"/>
             </a:solidFill>
             <a:prstDash val="solid"/>
           </a:ln>
         </p:spPr>
       </p:cxnSp>
-      <p:cxnSp>
-        <p:nvCxnSpPr>
-          <p:cNvPr id="633" name=""/>
-          <p:cNvCxnSpPr/>
-          <p:nvPr/>
-        </p:nvCxnSpPr>
-        <p:spPr>
-          <a:xfrm xmlns:a="http://schemas.openxmlformats.org/drawingml/2006/main">
-            <a:off x="6762750" y="3333750"/>
-            <a:ext cx="400050" cy="0"/>
-          </a:xfrm>
-          <a:prstGeom xmlns:a="http://schemas.openxmlformats.org/drawingml/2006/main" prst="straightConnector1">
-            <a:avLst/>
-          </a:prstGeom>
-          <a:ln xmlns:a="http://schemas.openxmlformats.org/drawingml/2006/main" w="19050">
-            <a:solidFill>
-              <a:srgbClr val="2478E5"/>
-            </a:solidFill>
-            <a:prstDash val="solid"/>
-          </a:ln>
-        </p:spPr>
-      </p:cxnSp>
-      <p:cxnSp>
-        <p:nvCxnSpPr>
-          <p:cNvPr id="634" name=""/>
-          <p:cNvCxnSpPr/>
-          <p:nvPr/>
-        </p:nvCxnSpPr>
-        <p:spPr>
-          <a:xfrm xmlns:a="http://schemas.openxmlformats.org/drawingml/2006/main">
-            <a:off x="9048750" y="3333750"/>
-            <a:ext cx="400050" cy="0"/>
-          </a:xfrm>
-          <a:prstGeom xmlns:a="http://schemas.openxmlformats.org/drawingml/2006/main" prst="straightConnector1">
-            <a:avLst/>
-          </a:prstGeom>
-          <a:ln xmlns:a="http://schemas.openxmlformats.org/drawingml/2006/main" w="19050">
-            <a:solidFill>
-              <a:srgbClr val="2478E5"/>
-            </a:solidFill>
-            <a:prstDash val="solid"/>
-          </a:ln>
-        </p:spPr>
-      </p:cxnSp>
-      <p:sp>
-        <p:nvSpPr>
-          <p:cNvPr id="11" name="">
-            <a:extLst xmlns:a="http://schemas.openxmlformats.org/drawingml/2006/main">
-              <a:ext uri="{FF2B5EF4-FFF2-40B4-BE49-F238E27FC236}">
-                <a16:creationId xmlns:a16="http://schemas.microsoft.com/office/drawing/2014/main" id="{F151358F-E088-428A-B623-2FBF6E55B81A}"/>
-              </a:ext>
-            </a:extLst>
-          </p:cNvPr>
-          <p:cNvSpPr>
-            <a:spLocks xmlns:a="http://schemas.openxmlformats.org/drawingml/2006/main" noGrp="1"/>
-          </p:cNvSpPr>
-          <p:nvPr/>
-        </p:nvSpPr>
-        <p:spPr>
-          <a:xfrm xmlns:a="http://schemas.openxmlformats.org/drawingml/2006/main">
-            <a:off x="400050" y="2638425"/>
-            <a:ext cx="1885950" cy="1466850"/>
+      <p:sp>
+        <p:nvSpPr>
+          <p:cNvPr id="18" name="">
+            <a:extLst xmlns:a="http://schemas.openxmlformats.org/drawingml/2006/main">
+              <a:ext uri="{FF2B5EF4-FFF2-40B4-BE49-F238E27FC236}">
+                <a16:creationId xmlns:a16="http://schemas.microsoft.com/office/drawing/2014/main" id="{E50AAA05-C9F4-41A3-8E51-7516AD09246A}"/>
+              </a:ext>
+            </a:extLst>
+          </p:cNvPr>
+          <p:cNvSpPr>
+            <a:spLocks xmlns:a="http://schemas.openxmlformats.org/drawingml/2006/main" noGrp="1"/>
+          </p:cNvSpPr>
+          <p:nvPr/>
+        </p:nvSpPr>
+        <p:spPr>
+          <a:xfrm xmlns:a="http://schemas.openxmlformats.org/drawingml/2006/main">
+            <a:off x="4505325" y="4962525"/>
+            <a:ext cx="952500" cy="209550"/>
+          </a:xfrm>
+          <a:prstGeom xmlns:a="http://schemas.openxmlformats.org/drawingml/2006/main" prst="rect">
+            <a:avLst/>
+          </a:prstGeom>
+          <a:noFill xmlns:a="http://schemas.openxmlformats.org/drawingml/2006/main"/>
+          <a:ln xmlns:a="http://schemas.openxmlformats.org/drawingml/2006/main" w="0">
+            <a:noFill/>
+            <a:prstDash val="solid"/>
+          </a:ln>
+        </p:spPr>
+        <p:txBody>
+          <a:bodyPr xmlns:a="http://schemas.openxmlformats.org/drawingml/2006/main" wrap="square" lIns="0" tIns="0" rIns="0" bIns="0" anchor="t">
+            <a:normAutofit fontScale="100000"/>
+          </a:bodyPr>
+          <a:lstStyle xmlns:a="http://schemas.openxmlformats.org/drawingml/2006/main"/>
+          <a:p xmlns:a="http://schemas.openxmlformats.org/drawingml/2006/main">
+            <a:pPr algn="l">
+              <a:buNone/>
+              <a:defRPr sz="975" b="1">
+                <a:solidFill>
+                  <a:srgbClr val="2478E5"/>
+                </a:solidFill>
+                <a:latin typeface="Noto Sans TC"/>
+                <a:ea typeface="Noto Sans TC"/>
+                <a:cs typeface="Noto Sans TC"/>
+              </a:defRPr>
+            </a:pPr>
+            <a:r>
+              <a:rPr sz="975" b="1">
+                <a:solidFill>
+                  <a:srgbClr val="2478E5"/>
+                </a:solidFill>
+                <a:latin typeface="Noto Sans TC"/>
+                <a:ea typeface="Noto Sans TC"/>
+                <a:cs typeface="Noto Sans TC"/>
+              </a:rPr>
+              <a:t>KEEPS</a:t>
+            </a:r>
+          </a:p>
+        </p:txBody>
+      </p:sp>
+      <p:sp>
+        <p:nvSpPr>
+          <p:cNvPr id="19" name="">
+            <a:extLst xmlns:a="http://schemas.openxmlformats.org/drawingml/2006/main">
+              <a:ext uri="{FF2B5EF4-FFF2-40B4-BE49-F238E27FC236}">
+                <a16:creationId xmlns:a16="http://schemas.microsoft.com/office/drawing/2014/main" id="{7F647F1E-5C6A-4C5D-9DA5-F8B7D34C4697}"/>
+              </a:ext>
+            </a:extLst>
+          </p:cNvPr>
+          <p:cNvSpPr>
+            <a:spLocks xmlns:a="http://schemas.openxmlformats.org/drawingml/2006/main" noGrp="1"/>
+          </p:cNvSpPr>
+          <p:nvPr/>
+        </p:nvSpPr>
+        <p:spPr>
+          <a:xfrm xmlns:a="http://schemas.openxmlformats.org/drawingml/2006/main">
+            <a:off x="4505325" y="5219700"/>
+            <a:ext cx="3000375" cy="438150"/>
+          </a:xfrm>
+          <a:prstGeom xmlns:a="http://schemas.openxmlformats.org/drawingml/2006/main" prst="rect">
+            <a:avLst/>
+          </a:prstGeom>
+          <a:noFill xmlns:a="http://schemas.openxmlformats.org/drawingml/2006/main"/>
+          <a:ln xmlns:a="http://schemas.openxmlformats.org/drawingml/2006/main" w="0">
+            <a:noFill/>
+            <a:prstDash val="solid"/>
+          </a:ln>
+        </p:spPr>
+        <p:txBody>
+          <a:bodyPr xmlns:a="http://schemas.openxmlformats.org/drawingml/2006/main" wrap="square" lIns="0" tIns="0" rIns="0" bIns="0" anchor="t">
+            <a:normAutofit fontScale="100000"/>
+          </a:bodyPr>
+          <a:lstStyle xmlns:a="http://schemas.openxmlformats.org/drawingml/2006/main"/>
+          <a:p xmlns:a="http://schemas.openxmlformats.org/drawingml/2006/main">
+            <a:pPr algn="l">
+              <a:buNone/>
+              <a:defRPr sz="1125" b="1">
+                <a:solidFill>
+                  <a:srgbClr val="173B57"/>
+                </a:solidFill>
+                <a:latin typeface="Noto Sans TC"/>
+                <a:ea typeface="Noto Sans TC"/>
+                <a:cs typeface="Noto Sans TC"/>
+              </a:defRPr>
+            </a:pPr>
+            <a:r>
+              <a:rPr sz="1125" b="1">
+                <a:solidFill>
+                  <a:srgbClr val="173B57"/>
+                </a:solidFill>
+                <a:latin typeface="Noto Sans TC"/>
+                <a:ea typeface="Noto Sans TC"/>
+                <a:cs typeface="Noto Sans TC"/>
+              </a:rPr>
+              <a:t>Context · SSOT · evidence</a:t>
+            </a:r>
+          </a:p>
+        </p:txBody>
+      </p:sp>
+      <p:sp>
+        <p:nvSpPr>
+          <p:cNvPr id="20" name="">
+            <a:extLst xmlns:a="http://schemas.openxmlformats.org/drawingml/2006/main">
+              <a:ext uri="{FF2B5EF4-FFF2-40B4-BE49-F238E27FC236}">
+                <a16:creationId xmlns:a16="http://schemas.microsoft.com/office/drawing/2014/main" id="{8655014B-D426-4312-9964-BB50BC02442C}"/>
+              </a:ext>
+            </a:extLst>
+          </p:cNvPr>
+          <p:cNvSpPr>
+            <a:spLocks xmlns:a="http://schemas.openxmlformats.org/drawingml/2006/main" noGrp="1"/>
+          </p:cNvSpPr>
+          <p:nvPr/>
+        </p:nvSpPr>
+        <p:spPr>
+          <a:xfrm xmlns:a="http://schemas.openxmlformats.org/drawingml/2006/main">
+            <a:off x="8153400" y="1619250"/>
+            <a:ext cx="3476625" cy="3905250"/>
           </a:xfrm>
           <a:prstGeom xmlns:a="http://schemas.openxmlformats.org/drawingml/2006/main" prst="rect">
             <a:avLst/>
@@ -3727,22 +4451,112 @@
       </p:sp>
       <p:sp>
         <p:nvSpPr>
-          <p:cNvPr id="12" name="">
-            <a:extLst xmlns:a="http://schemas.openxmlformats.org/drawingml/2006/main">
-              <a:ext uri="{FF2B5EF4-FFF2-40B4-BE49-F238E27FC236}">
-                <a16:creationId xmlns:a16="http://schemas.microsoft.com/office/drawing/2014/main" id="{B68B0859-CF74-45AC-AFD7-BD111C8E52F0}"/>
-              </a:ext>
-            </a:extLst>
-          </p:cNvPr>
-          <p:cNvSpPr>
-            <a:spLocks xmlns:a="http://schemas.openxmlformats.org/drawingml/2006/main" noGrp="1"/>
-          </p:cNvSpPr>
-          <p:nvPr/>
-        </p:nvSpPr>
-        <p:spPr>
-          <a:xfrm xmlns:a="http://schemas.openxmlformats.org/drawingml/2006/main">
-            <a:off x="571500" y="2800350"/>
-            <a:ext cx="381000" cy="285750"/>
+          <p:cNvPr id="21" name="">
+            <a:extLst xmlns:a="http://schemas.openxmlformats.org/drawingml/2006/main">
+              <a:ext uri="{FF2B5EF4-FFF2-40B4-BE49-F238E27FC236}">
+                <a16:creationId xmlns:a16="http://schemas.microsoft.com/office/drawing/2014/main" id="{B85509BE-B834-486F-9D0D-208CCDAB7E4B}"/>
+              </a:ext>
+            </a:extLst>
+          </p:cNvPr>
+          <p:cNvSpPr>
+            <a:spLocks xmlns:a="http://schemas.openxmlformats.org/drawingml/2006/main" noGrp="1"/>
+          </p:cNvSpPr>
+          <p:nvPr/>
+        </p:nvSpPr>
+        <p:spPr>
+          <a:xfrm xmlns:a="http://schemas.openxmlformats.org/drawingml/2006/main">
+            <a:off x="8153400" y="1619250"/>
+            <a:ext cx="3476625" cy="285750"/>
+          </a:xfrm>
+          <a:prstGeom xmlns:a="http://schemas.openxmlformats.org/drawingml/2006/main" prst="rect">
+            <a:avLst/>
+          </a:prstGeom>
+          <a:solidFill xmlns:a="http://schemas.openxmlformats.org/drawingml/2006/main">
+            <a:srgbClr val="173B57"/>
+          </a:solidFill>
+          <a:ln xmlns:a="http://schemas.openxmlformats.org/drawingml/2006/main" w="0">
+            <a:noFill/>
+            <a:prstDash val="solid"/>
+          </a:ln>
+        </p:spPr>
+      </p:sp>
+      <p:sp>
+        <p:nvSpPr>
+          <p:cNvPr id="22" name="">
+            <a:extLst xmlns:a="http://schemas.openxmlformats.org/drawingml/2006/main">
+              <a:ext uri="{FF2B5EF4-FFF2-40B4-BE49-F238E27FC236}">
+                <a16:creationId xmlns:a16="http://schemas.microsoft.com/office/drawing/2014/main" id="{76C849E1-4FD0-4CB6-955A-4697BB2D7886}"/>
+              </a:ext>
+            </a:extLst>
+          </p:cNvPr>
+          <p:cNvSpPr>
+            <a:spLocks xmlns:a="http://schemas.openxmlformats.org/drawingml/2006/main" noGrp="1"/>
+          </p:cNvSpPr>
+          <p:nvPr/>
+        </p:nvSpPr>
+        <p:spPr>
+          <a:xfrm xmlns:a="http://schemas.openxmlformats.org/drawingml/2006/main">
+            <a:off x="8248650" y="1676400"/>
+            <a:ext cx="3286125" cy="171450"/>
+          </a:xfrm>
+          <a:prstGeom xmlns:a="http://schemas.openxmlformats.org/drawingml/2006/main" prst="rect">
+            <a:avLst/>
+          </a:prstGeom>
+          <a:noFill xmlns:a="http://schemas.openxmlformats.org/drawingml/2006/main"/>
+          <a:ln xmlns:a="http://schemas.openxmlformats.org/drawingml/2006/main" w="0">
+            <a:noFill/>
+            <a:prstDash val="solid"/>
+          </a:ln>
+        </p:spPr>
+        <p:txBody>
+          <a:bodyPr xmlns:a="http://schemas.openxmlformats.org/drawingml/2006/main" wrap="square" lIns="0" tIns="0" rIns="0" bIns="0" anchor="ctr">
+            <a:normAutofit fontScale="100000"/>
+          </a:bodyPr>
+          <a:lstStyle xmlns:a="http://schemas.openxmlformats.org/drawingml/2006/main"/>
+          <a:p xmlns:a="http://schemas.openxmlformats.org/drawingml/2006/main">
+            <a:pPr algn="l">
+              <a:buNone/>
+              <a:defRPr sz="975" b="1">
+                <a:solidFill>
+                  <a:srgbClr val="FFFFFF"/>
+                </a:solidFill>
+                <a:latin typeface="Noto Sans TC"/>
+                <a:ea typeface="Noto Sans TC"/>
+                <a:cs typeface="Noto Sans TC"/>
+              </a:defRPr>
+            </a:pPr>
+            <a:r>
+              <a:rPr sz="975" b="1">
+                <a:solidFill>
+                  <a:srgbClr val="FFFFFF"/>
+                </a:solidFill>
+                <a:latin typeface="Noto Sans TC"/>
+                <a:ea typeface="Noto Sans TC"/>
+                <a:cs typeface="Noto Sans TC"/>
+              </a:rPr>
+              <a:t>AI EXECUTION</a:t>
+            </a:r>
+          </a:p>
+        </p:txBody>
+      </p:sp>
+      <p:sp>
+        <p:nvSpPr>
+          <p:cNvPr id="23" name="">
+            <a:extLst xmlns:a="http://schemas.openxmlformats.org/drawingml/2006/main">
+              <a:ext uri="{FF2B5EF4-FFF2-40B4-BE49-F238E27FC236}">
+                <a16:creationId xmlns:a16="http://schemas.microsoft.com/office/drawing/2014/main" id="{1EA2C016-5C5A-465D-ACE0-B92F537B4A73}"/>
+              </a:ext>
+            </a:extLst>
+          </p:cNvPr>
+          <p:cNvSpPr>
+            <a:spLocks xmlns:a="http://schemas.openxmlformats.org/drawingml/2006/main" noGrp="1"/>
+          </p:cNvSpPr>
+          <p:nvPr/>
+        </p:nvSpPr>
+        <p:spPr>
+          <a:xfrm xmlns:a="http://schemas.openxmlformats.org/drawingml/2006/main">
+            <a:off x="8382000" y="2152650"/>
+            <a:ext cx="3000375" cy="304800"/>
           </a:xfrm>
           <a:prstGeom xmlns:a="http://schemas.openxmlformats.org/drawingml/2006/main" prst="rect">
             <a:avLst/>
@@ -3761,47 +4575,47 @@
           <a:p xmlns:a="http://schemas.openxmlformats.org/drawingml/2006/main">
             <a:pPr algn="l">
               <a:buNone/>
-              <a:defRPr sz="1650" b="1">
-                <a:solidFill>
-                  <a:srgbClr val="2478E5"/>
-                </a:solidFill>
-                <a:latin typeface="Noto Sans TC"/>
-                <a:ea typeface="Noto Sans TC"/>
-                <a:cs typeface="Noto Sans TC"/>
-              </a:defRPr>
-            </a:pPr>
-            <a:r>
-              <a:rPr sz="1650" b="1">
-                <a:solidFill>
-                  <a:srgbClr val="2478E5"/>
-                </a:solidFill>
-                <a:latin typeface="Noto Sans TC"/>
-                <a:ea typeface="Noto Sans TC"/>
-                <a:cs typeface="Noto Sans TC"/>
-              </a:rPr>
-              <a:t>1</a:t>
-            </a:r>
-          </a:p>
-        </p:txBody>
-      </p:sp>
-      <p:sp>
-        <p:nvSpPr>
-          <p:cNvPr id="13" name="">
-            <a:extLst xmlns:a="http://schemas.openxmlformats.org/drawingml/2006/main">
-              <a:ext uri="{FF2B5EF4-FFF2-40B4-BE49-F238E27FC236}">
-                <a16:creationId xmlns:a16="http://schemas.microsoft.com/office/drawing/2014/main" id="{56C1B6FF-1833-439F-96BC-617A9A084FC8}"/>
-              </a:ext>
-            </a:extLst>
-          </p:cNvPr>
-          <p:cNvSpPr>
-            <a:spLocks xmlns:a="http://schemas.openxmlformats.org/drawingml/2006/main" noGrp="1"/>
-          </p:cNvSpPr>
-          <p:nvPr/>
-        </p:nvSpPr>
-        <p:spPr>
-          <a:xfrm xmlns:a="http://schemas.openxmlformats.org/drawingml/2006/main">
-            <a:off x="571500" y="3171825"/>
-            <a:ext cx="1543050" cy="304800"/>
+              <a:defRPr sz="1725" b="1">
+                <a:solidFill>
+                  <a:srgbClr val="111111"/>
+                </a:solidFill>
+                <a:latin typeface="Noto Sans TC"/>
+                <a:ea typeface="Noto Sans TC"/>
+                <a:cs typeface="Noto Sans TC"/>
+              </a:defRPr>
+            </a:pPr>
+            <a:r>
+              <a:rPr sz="1725" b="1">
+                <a:solidFill>
+                  <a:srgbClr val="111111"/>
+                </a:solidFill>
+                <a:latin typeface="Noto Sans TC"/>
+                <a:ea typeface="Noto Sans TC"/>
+                <a:cs typeface="Noto Sans TC"/>
+              </a:rPr>
+              <a:t>AI 加速執行</a:t>
+            </a:r>
+          </a:p>
+        </p:txBody>
+      </p:sp>
+      <p:sp>
+        <p:nvSpPr>
+          <p:cNvPr id="24" name="">
+            <a:extLst xmlns:a="http://schemas.openxmlformats.org/drawingml/2006/main">
+              <a:ext uri="{FF2B5EF4-FFF2-40B4-BE49-F238E27FC236}">
+                <a16:creationId xmlns:a16="http://schemas.microsoft.com/office/drawing/2014/main" id="{6E8B0C43-A552-45B0-BE18-D69845272384}"/>
+              </a:ext>
+            </a:extLst>
+          </p:cNvPr>
+          <p:cNvSpPr>
+            <a:spLocks xmlns:a="http://schemas.openxmlformats.org/drawingml/2006/main" noGrp="1"/>
+          </p:cNvSpPr>
+          <p:nvPr/>
+        </p:nvSpPr>
+        <p:spPr>
+          <a:xfrm xmlns:a="http://schemas.openxmlformats.org/drawingml/2006/main">
+            <a:off x="8382000" y="2714625"/>
+            <a:ext cx="3000375" cy="1809750"/>
           </a:xfrm>
           <a:prstGeom xmlns:a="http://schemas.openxmlformats.org/drawingml/2006/main" prst="rect">
             <a:avLst/>
@@ -3820,47 +4634,141 @@
           <a:p xmlns:a="http://schemas.openxmlformats.org/drawingml/2006/main">
             <a:pPr algn="l">
               <a:buNone/>
-              <a:defRPr sz="1725" b="1">
-                <a:solidFill>
-                  <a:srgbClr val="111111"/>
-                </a:solidFill>
-                <a:latin typeface="Noto Sans TC"/>
-                <a:ea typeface="Noto Sans TC"/>
-                <a:cs typeface="Noto Sans TC"/>
-              </a:defRPr>
-            </a:pPr>
-            <a:r>
-              <a:rPr sz="1725" b="1">
-                <a:solidFill>
-                  <a:srgbClr val="111111"/>
-                </a:solidFill>
-                <a:latin typeface="Noto Sans TC"/>
-                <a:ea typeface="Noto Sans TC"/>
-                <a:cs typeface="Noto Sans TC"/>
-              </a:rPr>
-              <a:t>Research</a:t>
-            </a:r>
-          </a:p>
-        </p:txBody>
-      </p:sp>
-      <p:sp>
-        <p:nvSpPr>
-          <p:cNvPr id="14" name="">
-            <a:extLst xmlns:a="http://schemas.openxmlformats.org/drawingml/2006/main">
-              <a:ext uri="{FF2B5EF4-FFF2-40B4-BE49-F238E27FC236}">
-                <a16:creationId xmlns:a16="http://schemas.microsoft.com/office/drawing/2014/main" id="{E8C60667-E9B8-4E21-9DB8-650874177277}"/>
-              </a:ext>
-            </a:extLst>
-          </p:cNvPr>
-          <p:cNvSpPr>
-            <a:spLocks xmlns:a="http://schemas.openxmlformats.org/drawingml/2006/main" noGrp="1"/>
-          </p:cNvSpPr>
-          <p:nvPr/>
-        </p:nvSpPr>
-        <p:spPr>
-          <a:xfrm xmlns:a="http://schemas.openxmlformats.org/drawingml/2006/main">
-            <a:off x="571500" y="3600450"/>
-            <a:ext cx="1543050" cy="381000"/>
+              <a:defRPr sz="1275" b="0">
+                <a:solidFill>
+                  <a:srgbClr val="111111"/>
+                </a:solidFill>
+                <a:latin typeface="Noto Sans TC"/>
+                <a:ea typeface="Noto Sans TC"/>
+                <a:cs typeface="Noto Sans TC"/>
+              </a:defRPr>
+            </a:pPr>
+            <a:r>
+              <a:rPr sz="1275" b="0">
+                <a:solidFill>
+                  <a:srgbClr val="111111"/>
+                </a:solidFill>
+                <a:latin typeface="Noto Sans TC"/>
+                <a:ea typeface="Noto Sans TC"/>
+                <a:cs typeface="Noto Sans TC"/>
+              </a:rPr>
+              <a:t>Research / synthesis</a:t>
+            </a:r>
+          </a:p>
+          <a:p xmlns:a="http://schemas.openxmlformats.org/drawingml/2006/main">
+            <a:pPr algn="l">
+              <a:buNone/>
+              <a:defRPr sz="1275" b="0">
+                <a:solidFill>
+                  <a:srgbClr val="111111"/>
+                </a:solidFill>
+                <a:latin typeface="Noto Sans TC"/>
+                <a:ea typeface="Noto Sans TC"/>
+                <a:cs typeface="Noto Sans TC"/>
+              </a:defRPr>
+            </a:pPr>
+            <a:r>
+              <a:rPr sz="1275" b="0">
+                <a:solidFill>
+                  <a:srgbClr val="111111"/>
+                </a:solidFill>
+                <a:latin typeface="Noto Sans TC"/>
+                <a:ea typeface="Noto Sans TC"/>
+                <a:cs typeface="Noto Sans TC"/>
+              </a:rPr>
+              <a:t>Implementation / TDD</a:t>
+            </a:r>
+          </a:p>
+          <a:p xmlns:a="http://schemas.openxmlformats.org/drawingml/2006/main">
+            <a:pPr algn="l">
+              <a:buNone/>
+              <a:defRPr sz="1275" b="0">
+                <a:solidFill>
+                  <a:srgbClr val="111111"/>
+                </a:solidFill>
+                <a:latin typeface="Noto Sans TC"/>
+                <a:ea typeface="Noto Sans TC"/>
+                <a:cs typeface="Noto Sans TC"/>
+              </a:defRPr>
+            </a:pPr>
+            <a:r>
+              <a:rPr sz="1275" b="0">
+                <a:solidFill>
+                  <a:srgbClr val="111111"/>
+                </a:solidFill>
+                <a:latin typeface="Noto Sans TC"/>
+                <a:ea typeface="Noto Sans TC"/>
+                <a:cs typeface="Noto Sans TC"/>
+              </a:rPr>
+              <a:t>Review / verification</a:t>
+            </a:r>
+          </a:p>
+          <a:p xmlns:a="http://schemas.openxmlformats.org/drawingml/2006/main">
+            <a:pPr algn="l">
+              <a:buNone/>
+              <a:defRPr sz="1275" b="0">
+                <a:solidFill>
+                  <a:srgbClr val="111111"/>
+                </a:solidFill>
+                <a:latin typeface="Noto Sans TC"/>
+                <a:ea typeface="Noto Sans TC"/>
+                <a:cs typeface="Noto Sans TC"/>
+              </a:defRPr>
+            </a:pPr>
+            <a:r>
+              <a:rPr sz="1275" b="0">
+                <a:solidFill>
+                  <a:srgbClr val="111111"/>
+                </a:solidFill>
+                <a:latin typeface="Noto Sans TC"/>
+                <a:ea typeface="Noto Sans TC"/>
+                <a:cs typeface="Noto Sans TC"/>
+              </a:rPr>
+              <a:t>Subagents / automation</a:t>
+            </a:r>
+          </a:p>
+        </p:txBody>
+      </p:sp>
+      <p:cxnSp>
+        <p:nvCxnSpPr>
+          <p:cNvPr id="678" name=""/>
+          <p:cNvCxnSpPr/>
+          <p:nvPr/>
+        </p:nvCxnSpPr>
+        <p:spPr>
+          <a:xfrm xmlns:a="http://schemas.openxmlformats.org/drawingml/2006/main">
+            <a:off x="8382000" y="4762500"/>
+            <a:ext cx="3019425" cy="0"/>
+          </a:xfrm>
+          <a:prstGeom xmlns:a="http://schemas.openxmlformats.org/drawingml/2006/main" prst="straightConnector1">
+            <a:avLst/>
+          </a:prstGeom>
+          <a:ln xmlns:a="http://schemas.openxmlformats.org/drawingml/2006/main" w="9525">
+            <a:solidFill>
+              <a:srgbClr val="B8BCC4"/>
+            </a:solidFill>
+            <a:prstDash val="solid"/>
+          </a:ln>
+        </p:spPr>
+      </p:cxnSp>
+      <p:sp>
+        <p:nvSpPr>
+          <p:cNvPr id="26" name="">
+            <a:extLst xmlns:a="http://schemas.openxmlformats.org/drawingml/2006/main">
+              <a:ext uri="{FF2B5EF4-FFF2-40B4-BE49-F238E27FC236}">
+                <a16:creationId xmlns:a16="http://schemas.microsoft.com/office/drawing/2014/main" id="{19736404-A14D-4C18-A696-0256E9DC55BE}"/>
+              </a:ext>
+            </a:extLst>
+          </p:cNvPr>
+          <p:cNvSpPr>
+            <a:spLocks xmlns:a="http://schemas.openxmlformats.org/drawingml/2006/main" noGrp="1"/>
+          </p:cNvSpPr>
+          <p:nvPr/>
+        </p:nvSpPr>
+        <p:spPr>
+          <a:xfrm xmlns:a="http://schemas.openxmlformats.org/drawingml/2006/main">
+            <a:off x="8382000" y="4962525"/>
+            <a:ext cx="952500" cy="209550"/>
           </a:xfrm>
           <a:prstGeom xmlns:a="http://schemas.openxmlformats.org/drawingml/2006/main" prst="rect">
             <a:avLst/>
@@ -3879,78 +4787,47 @@
           <a:p xmlns:a="http://schemas.openxmlformats.org/drawingml/2006/main">
             <a:pPr algn="l">
               <a:buNone/>
-              <a:defRPr sz="1125" b="0">
-                <a:solidFill>
-                  <a:srgbClr val="5C6570"/>
-                </a:solidFill>
-                <a:latin typeface="Noto Sans TC"/>
-                <a:ea typeface="Noto Sans TC"/>
-                <a:cs typeface="Noto Sans TC"/>
-              </a:defRPr>
-            </a:pPr>
-            <a:r>
-              <a:rPr sz="1125" b="0">
-                <a:solidFill>
-                  <a:srgbClr val="5C6570"/>
-                </a:solidFill>
-                <a:latin typeface="Noto Sans TC"/>
-                <a:ea typeface="Noto Sans TC"/>
-                <a:cs typeface="Noto Sans TC"/>
-              </a:rPr>
-              <a:t>Problem · system · unknowns</a:t>
-            </a:r>
-          </a:p>
-        </p:txBody>
-      </p:sp>
-      <p:sp>
-        <p:nvSpPr>
-          <p:cNvPr id="15" name="">
-            <a:extLst xmlns:a="http://schemas.openxmlformats.org/drawingml/2006/main">
-              <a:ext uri="{FF2B5EF4-FFF2-40B4-BE49-F238E27FC236}">
-                <a16:creationId xmlns:a16="http://schemas.microsoft.com/office/drawing/2014/main" id="{DD74A4D7-EF87-46F2-8EC4-41EFAD2DBCD1}"/>
-              </a:ext>
-            </a:extLst>
-          </p:cNvPr>
-          <p:cNvSpPr>
-            <a:spLocks xmlns:a="http://schemas.openxmlformats.org/drawingml/2006/main" noGrp="1"/>
-          </p:cNvSpPr>
-          <p:nvPr/>
-        </p:nvSpPr>
-        <p:spPr>
-          <a:xfrm xmlns:a="http://schemas.openxmlformats.org/drawingml/2006/main">
-            <a:off x="2686050" y="2638425"/>
-            <a:ext cx="1885950" cy="1466850"/>
-          </a:xfrm>
-          <a:prstGeom xmlns:a="http://schemas.openxmlformats.org/drawingml/2006/main" prst="rect">
-            <a:avLst/>
-          </a:prstGeom>
-          <a:solidFill xmlns:a="http://schemas.openxmlformats.org/drawingml/2006/main">
-            <a:srgbClr val="F1F2F3"/>
-          </a:solidFill>
-          <a:ln xmlns:a="http://schemas.openxmlformats.org/drawingml/2006/main" w="0">
-            <a:noFill/>
-            <a:prstDash val="solid"/>
-          </a:ln>
-        </p:spPr>
-      </p:sp>
-      <p:sp>
-        <p:nvSpPr>
-          <p:cNvPr id="16" name="">
-            <a:extLst xmlns:a="http://schemas.openxmlformats.org/drawingml/2006/main">
-              <a:ext uri="{FF2B5EF4-FFF2-40B4-BE49-F238E27FC236}">
-                <a16:creationId xmlns:a16="http://schemas.microsoft.com/office/drawing/2014/main" id="{0EB5FAAF-F5C6-4501-AC14-23FEB13A99C0}"/>
-              </a:ext>
-            </a:extLst>
-          </p:cNvPr>
-          <p:cNvSpPr>
-            <a:spLocks xmlns:a="http://schemas.openxmlformats.org/drawingml/2006/main" noGrp="1"/>
-          </p:cNvSpPr>
-          <p:nvPr/>
-        </p:nvSpPr>
-        <p:spPr>
-          <a:xfrm xmlns:a="http://schemas.openxmlformats.org/drawingml/2006/main">
-            <a:off x="2857500" y="2800350"/>
-            <a:ext cx="381000" cy="285750"/>
+              <a:defRPr sz="975" b="1">
+                <a:solidFill>
+                  <a:srgbClr val="2478E5"/>
+                </a:solidFill>
+                <a:latin typeface="Noto Sans TC"/>
+                <a:ea typeface="Noto Sans TC"/>
+                <a:cs typeface="Noto Sans TC"/>
+              </a:defRPr>
+            </a:pPr>
+            <a:r>
+              <a:rPr sz="975" b="1">
+                <a:solidFill>
+                  <a:srgbClr val="2478E5"/>
+                </a:solidFill>
+                <a:latin typeface="Noto Sans TC"/>
+                <a:ea typeface="Noto Sans TC"/>
+                <a:cs typeface="Noto Sans TC"/>
+              </a:rPr>
+              <a:t>ACCELERATES</a:t>
+            </a:r>
+          </a:p>
+        </p:txBody>
+      </p:sp>
+      <p:sp>
+        <p:nvSpPr>
+          <p:cNvPr id="27" name="">
+            <a:extLst xmlns:a="http://schemas.openxmlformats.org/drawingml/2006/main">
+              <a:ext uri="{FF2B5EF4-FFF2-40B4-BE49-F238E27FC236}">
+                <a16:creationId xmlns:a16="http://schemas.microsoft.com/office/drawing/2014/main" id="{B46CEE82-16AE-4E5F-95FD-6B69D0ED281F}"/>
+              </a:ext>
+            </a:extLst>
+          </p:cNvPr>
+          <p:cNvSpPr>
+            <a:spLocks xmlns:a="http://schemas.openxmlformats.org/drawingml/2006/main" noGrp="1"/>
+          </p:cNvSpPr>
+          <p:nvPr/>
+        </p:nvSpPr>
+        <p:spPr>
+          <a:xfrm xmlns:a="http://schemas.openxmlformats.org/drawingml/2006/main">
+            <a:off x="8382000" y="5219700"/>
+            <a:ext cx="3000375" cy="438150"/>
           </a:xfrm>
           <a:prstGeom xmlns:a="http://schemas.openxmlformats.org/drawingml/2006/main" prst="rect">
             <a:avLst/>
@@ -3969,52 +4846,54 @@
           <a:p xmlns:a="http://schemas.openxmlformats.org/drawingml/2006/main">
             <a:pPr algn="l">
               <a:buNone/>
-              <a:defRPr sz="1650" b="1">
-                <a:solidFill>
-                  <a:srgbClr val="2478E5"/>
-                </a:solidFill>
-                <a:latin typeface="Noto Sans TC"/>
-                <a:ea typeface="Noto Sans TC"/>
-                <a:cs typeface="Noto Sans TC"/>
-              </a:defRPr>
-            </a:pPr>
-            <a:r>
-              <a:rPr sz="1650" b="1">
-                <a:solidFill>
-                  <a:srgbClr val="2478E5"/>
-                </a:solidFill>
-                <a:latin typeface="Noto Sans TC"/>
-                <a:ea typeface="Noto Sans TC"/>
-                <a:cs typeface="Noto Sans TC"/>
-              </a:rPr>
-              <a:t>2</a:t>
-            </a:r>
-          </a:p>
-        </p:txBody>
-      </p:sp>
-      <p:sp>
-        <p:nvSpPr>
-          <p:cNvPr id="17" name="">
-            <a:extLst xmlns:a="http://schemas.openxmlformats.org/drawingml/2006/main">
-              <a:ext uri="{FF2B5EF4-FFF2-40B4-BE49-F238E27FC236}">
-                <a16:creationId xmlns:a16="http://schemas.microsoft.com/office/drawing/2014/main" id="{A584C97B-95D7-412C-8A35-EB23D4758418}"/>
-              </a:ext>
-            </a:extLst>
-          </p:cNvPr>
-          <p:cNvSpPr>
-            <a:spLocks xmlns:a="http://schemas.openxmlformats.org/drawingml/2006/main" noGrp="1"/>
-          </p:cNvSpPr>
-          <p:nvPr/>
-        </p:nvSpPr>
-        <p:spPr>
-          <a:xfrm xmlns:a="http://schemas.openxmlformats.org/drawingml/2006/main">
-            <a:off x="2857500" y="3171825"/>
-            <a:ext cx="1543050" cy="304800"/>
-          </a:xfrm>
-          <a:prstGeom xmlns:a="http://schemas.openxmlformats.org/drawingml/2006/main" prst="rect">
-            <a:avLst/>
-          </a:prstGeom>
-          <a:noFill xmlns:a="http://schemas.openxmlformats.org/drawingml/2006/main"/>
+              <a:defRPr sz="1125" b="1">
+                <a:solidFill>
+                  <a:srgbClr val="173B57"/>
+                </a:solidFill>
+                <a:latin typeface="Noto Sans TC"/>
+                <a:ea typeface="Noto Sans TC"/>
+                <a:cs typeface="Noto Sans TC"/>
+              </a:defRPr>
+            </a:pPr>
+            <a:r>
+              <a:rPr sz="1125" b="1">
+                <a:solidFill>
+                  <a:srgbClr val="173B57"/>
+                </a:solidFill>
+                <a:latin typeface="Noto Sans TC"/>
+                <a:ea typeface="Noto Sans TC"/>
+                <a:cs typeface="Noto Sans TC"/>
+              </a:rPr>
+              <a:t>Speed · scale · feedback</a:t>
+            </a:r>
+          </a:p>
+        </p:txBody>
+      </p:sp>
+      <p:sp>
+        <p:nvSpPr>
+          <p:cNvPr id="28" name="">
+            <a:extLst xmlns:a="http://schemas.openxmlformats.org/drawingml/2006/main">
+              <a:ext uri="{FF2B5EF4-FFF2-40B4-BE49-F238E27FC236}">
+                <a16:creationId xmlns:a16="http://schemas.microsoft.com/office/drawing/2014/main" id="{6563E22B-FC08-462D-B6F0-B9AA25B49D02}"/>
+              </a:ext>
+            </a:extLst>
+          </p:cNvPr>
+          <p:cNvSpPr>
+            <a:spLocks xmlns:a="http://schemas.openxmlformats.org/drawingml/2006/main" noGrp="1"/>
+          </p:cNvSpPr>
+          <p:nvPr/>
+        </p:nvSpPr>
+        <p:spPr>
+          <a:xfrm xmlns:a="http://schemas.openxmlformats.org/drawingml/2006/main">
+            <a:off x="400050" y="5676900"/>
+            <a:ext cx="11391900" cy="571500"/>
+          </a:xfrm>
+          <a:prstGeom xmlns:a="http://schemas.openxmlformats.org/drawingml/2006/main" prst="rect">
+            <a:avLst/>
+          </a:prstGeom>
+          <a:solidFill xmlns:a="http://schemas.openxmlformats.org/drawingml/2006/main">
+            <a:srgbClr val="FFF1CC"/>
+          </a:solidFill>
           <a:ln xmlns:a="http://schemas.openxmlformats.org/drawingml/2006/main" w="0">
             <a:noFill/>
             <a:prstDash val="solid"/>
@@ -4028,938 +4907,25 @@
           <a:p xmlns:a="http://schemas.openxmlformats.org/drawingml/2006/main">
             <a:pPr algn="l">
               <a:buNone/>
-              <a:defRPr sz="1725" b="1">
-                <a:solidFill>
-                  <a:srgbClr val="111111"/>
-                </a:solidFill>
-                <a:latin typeface="Noto Sans TC"/>
-                <a:ea typeface="Noto Sans TC"/>
-                <a:cs typeface="Noto Sans TC"/>
-              </a:defRPr>
-            </a:pPr>
-            <a:r>
-              <a:rPr sz="1725" b="1">
-                <a:solidFill>
-                  <a:srgbClr val="111111"/>
-                </a:solidFill>
-                <a:latin typeface="Noto Sans TC"/>
-                <a:ea typeface="Noto Sans TC"/>
-                <a:cs typeface="Noto Sans TC"/>
-              </a:rPr>
-              <a:t>Design</a:t>
-            </a:r>
-          </a:p>
-        </p:txBody>
-      </p:sp>
-      <p:sp>
-        <p:nvSpPr>
-          <p:cNvPr id="18" name="">
-            <a:extLst xmlns:a="http://schemas.openxmlformats.org/drawingml/2006/main">
-              <a:ext uri="{FF2B5EF4-FFF2-40B4-BE49-F238E27FC236}">
-                <a16:creationId xmlns:a16="http://schemas.microsoft.com/office/drawing/2014/main" id="{6F787A97-2730-4256-A4F9-8FB19B7F5505}"/>
-              </a:ext>
-            </a:extLst>
-          </p:cNvPr>
-          <p:cNvSpPr>
-            <a:spLocks xmlns:a="http://schemas.openxmlformats.org/drawingml/2006/main" noGrp="1"/>
-          </p:cNvSpPr>
-          <p:nvPr/>
-        </p:nvSpPr>
-        <p:spPr>
-          <a:xfrm xmlns:a="http://schemas.openxmlformats.org/drawingml/2006/main">
-            <a:off x="2857500" y="3600450"/>
-            <a:ext cx="1543050" cy="381000"/>
-          </a:xfrm>
-          <a:prstGeom xmlns:a="http://schemas.openxmlformats.org/drawingml/2006/main" prst="rect">
-            <a:avLst/>
-          </a:prstGeom>
-          <a:noFill xmlns:a="http://schemas.openxmlformats.org/drawingml/2006/main"/>
-          <a:ln xmlns:a="http://schemas.openxmlformats.org/drawingml/2006/main" w="0">
-            <a:noFill/>
-            <a:prstDash val="solid"/>
-          </a:ln>
-        </p:spPr>
-        <p:txBody>
-          <a:bodyPr xmlns:a="http://schemas.openxmlformats.org/drawingml/2006/main" wrap="square" lIns="0" tIns="0" rIns="0" bIns="0" anchor="t">
-            <a:normAutofit fontScale="100000"/>
-          </a:bodyPr>
-          <a:lstStyle xmlns:a="http://schemas.openxmlformats.org/drawingml/2006/main"/>
-          <a:p xmlns:a="http://schemas.openxmlformats.org/drawingml/2006/main">
-            <a:pPr algn="l">
-              <a:buNone/>
-              <a:defRPr sz="1125" b="0">
-                <a:solidFill>
-                  <a:srgbClr val="5C6570"/>
-                </a:solidFill>
-                <a:latin typeface="Noto Sans TC"/>
-                <a:ea typeface="Noto Sans TC"/>
-                <a:cs typeface="Noto Sans TC"/>
-              </a:defRPr>
-            </a:pPr>
-            <a:r>
-              <a:rPr sz="1125" b="0">
-                <a:solidFill>
-                  <a:srgbClr val="5C6570"/>
-                </a:solidFill>
-                <a:latin typeface="Noto Sans TC"/>
-                <a:ea typeface="Noto Sans TC"/>
-                <a:cs typeface="Noto Sans TC"/>
-              </a:rPr>
-              <a:t>FR · NFR · boundary · trade-offs</a:t>
-            </a:r>
-          </a:p>
-        </p:txBody>
-      </p:sp>
-      <p:sp>
-        <p:nvSpPr>
-          <p:cNvPr id="19" name="">
-            <a:extLst xmlns:a="http://schemas.openxmlformats.org/drawingml/2006/main">
-              <a:ext uri="{FF2B5EF4-FFF2-40B4-BE49-F238E27FC236}">
-                <a16:creationId xmlns:a16="http://schemas.microsoft.com/office/drawing/2014/main" id="{FF15B2F2-4EA5-4B3B-B9BD-52E53AA9171A}"/>
-              </a:ext>
-            </a:extLst>
-          </p:cNvPr>
-          <p:cNvSpPr>
-            <a:spLocks xmlns:a="http://schemas.openxmlformats.org/drawingml/2006/main" noGrp="1"/>
-          </p:cNvSpPr>
-          <p:nvPr/>
-        </p:nvSpPr>
-        <p:spPr>
-          <a:xfrm xmlns:a="http://schemas.openxmlformats.org/drawingml/2006/main">
-            <a:off x="4972050" y="2638425"/>
-            <a:ext cx="1885950" cy="1466850"/>
-          </a:xfrm>
-          <a:prstGeom xmlns:a="http://schemas.openxmlformats.org/drawingml/2006/main" prst="rect">
-            <a:avLst/>
-          </a:prstGeom>
-          <a:solidFill xmlns:a="http://schemas.openxmlformats.org/drawingml/2006/main">
-            <a:srgbClr val="E7EAED"/>
-          </a:solidFill>
-          <a:ln xmlns:a="http://schemas.openxmlformats.org/drawingml/2006/main" w="0">
-            <a:noFill/>
-            <a:prstDash val="solid"/>
-          </a:ln>
-        </p:spPr>
-      </p:sp>
-      <p:sp>
-        <p:nvSpPr>
-          <p:cNvPr id="20" name="">
-            <a:extLst xmlns:a="http://schemas.openxmlformats.org/drawingml/2006/main">
-              <a:ext uri="{FF2B5EF4-FFF2-40B4-BE49-F238E27FC236}">
-                <a16:creationId xmlns:a16="http://schemas.microsoft.com/office/drawing/2014/main" id="{27FDB9E7-C060-41E7-A080-BE7088D44FF7}"/>
-              </a:ext>
-            </a:extLst>
-          </p:cNvPr>
-          <p:cNvSpPr>
-            <a:spLocks xmlns:a="http://schemas.openxmlformats.org/drawingml/2006/main" noGrp="1"/>
-          </p:cNvSpPr>
-          <p:nvPr/>
-        </p:nvSpPr>
-        <p:spPr>
-          <a:xfrm xmlns:a="http://schemas.openxmlformats.org/drawingml/2006/main">
-            <a:off x="5143500" y="2800350"/>
-            <a:ext cx="381000" cy="285750"/>
-          </a:xfrm>
-          <a:prstGeom xmlns:a="http://schemas.openxmlformats.org/drawingml/2006/main" prst="rect">
-            <a:avLst/>
-          </a:prstGeom>
-          <a:noFill xmlns:a="http://schemas.openxmlformats.org/drawingml/2006/main"/>
-          <a:ln xmlns:a="http://schemas.openxmlformats.org/drawingml/2006/main" w="0">
-            <a:noFill/>
-            <a:prstDash val="solid"/>
-          </a:ln>
-        </p:spPr>
-        <p:txBody>
-          <a:bodyPr xmlns:a="http://schemas.openxmlformats.org/drawingml/2006/main" wrap="square" lIns="0" tIns="0" rIns="0" bIns="0" anchor="t">
-            <a:normAutofit fontScale="100000"/>
-          </a:bodyPr>
-          <a:lstStyle xmlns:a="http://schemas.openxmlformats.org/drawingml/2006/main"/>
-          <a:p xmlns:a="http://schemas.openxmlformats.org/drawingml/2006/main">
-            <a:pPr algn="l">
-              <a:buNone/>
-              <a:defRPr sz="1650" b="1">
-                <a:solidFill>
-                  <a:srgbClr val="2478E5"/>
-                </a:solidFill>
-                <a:latin typeface="Noto Sans TC"/>
-                <a:ea typeface="Noto Sans TC"/>
-                <a:cs typeface="Noto Sans TC"/>
-              </a:defRPr>
-            </a:pPr>
-            <a:r>
-              <a:rPr sz="1650" b="1">
-                <a:solidFill>
-                  <a:srgbClr val="2478E5"/>
-                </a:solidFill>
-                <a:latin typeface="Noto Sans TC"/>
-                <a:ea typeface="Noto Sans TC"/>
-                <a:cs typeface="Noto Sans TC"/>
-              </a:rPr>
-              <a:t>3</a:t>
-            </a:r>
-          </a:p>
-        </p:txBody>
-      </p:sp>
-      <p:sp>
-        <p:nvSpPr>
-          <p:cNvPr id="21" name="">
-            <a:extLst xmlns:a="http://schemas.openxmlformats.org/drawingml/2006/main">
-              <a:ext uri="{FF2B5EF4-FFF2-40B4-BE49-F238E27FC236}">
-                <a16:creationId xmlns:a16="http://schemas.microsoft.com/office/drawing/2014/main" id="{E2982BA4-2011-4057-917D-C12E55C5BCFA}"/>
-              </a:ext>
-            </a:extLst>
-          </p:cNvPr>
-          <p:cNvSpPr>
-            <a:spLocks xmlns:a="http://schemas.openxmlformats.org/drawingml/2006/main" noGrp="1"/>
-          </p:cNvSpPr>
-          <p:nvPr/>
-        </p:nvSpPr>
-        <p:spPr>
-          <a:xfrm xmlns:a="http://schemas.openxmlformats.org/drawingml/2006/main">
-            <a:off x="5143500" y="3171825"/>
-            <a:ext cx="1543050" cy="304800"/>
-          </a:xfrm>
-          <a:prstGeom xmlns:a="http://schemas.openxmlformats.org/drawingml/2006/main" prst="rect">
-            <a:avLst/>
-          </a:prstGeom>
-          <a:noFill xmlns:a="http://schemas.openxmlformats.org/drawingml/2006/main"/>
-          <a:ln xmlns:a="http://schemas.openxmlformats.org/drawingml/2006/main" w="0">
-            <a:noFill/>
-            <a:prstDash val="solid"/>
-          </a:ln>
-        </p:spPr>
-        <p:txBody>
-          <a:bodyPr xmlns:a="http://schemas.openxmlformats.org/drawingml/2006/main" wrap="square" lIns="0" tIns="0" rIns="0" bIns="0" anchor="t">
-            <a:normAutofit fontScale="100000"/>
-          </a:bodyPr>
-          <a:lstStyle xmlns:a="http://schemas.openxmlformats.org/drawingml/2006/main"/>
-          <a:p xmlns:a="http://schemas.openxmlformats.org/drawingml/2006/main">
-            <a:pPr algn="l">
-              <a:buNone/>
-              <a:defRPr sz="1725" b="1">
-                <a:solidFill>
-                  <a:srgbClr val="111111"/>
-                </a:solidFill>
-                <a:latin typeface="Noto Sans TC"/>
-                <a:ea typeface="Noto Sans TC"/>
-                <a:cs typeface="Noto Sans TC"/>
-              </a:defRPr>
-            </a:pPr>
-            <a:r>
-              <a:rPr sz="1725" b="1">
-                <a:solidFill>
-                  <a:srgbClr val="111111"/>
-                </a:solidFill>
-                <a:latin typeface="Noto Sans TC"/>
-                <a:ea typeface="Noto Sans TC"/>
-                <a:cs typeface="Noto Sans TC"/>
-              </a:rPr>
-              <a:t>Plan</a:t>
-            </a:r>
-          </a:p>
-        </p:txBody>
-      </p:sp>
-      <p:sp>
-        <p:nvSpPr>
-          <p:cNvPr id="22" name="">
-            <a:extLst xmlns:a="http://schemas.openxmlformats.org/drawingml/2006/main">
-              <a:ext uri="{FF2B5EF4-FFF2-40B4-BE49-F238E27FC236}">
-                <a16:creationId xmlns:a16="http://schemas.microsoft.com/office/drawing/2014/main" id="{ED1AE2E6-D809-4519-87BC-D640C5054200}"/>
-              </a:ext>
-            </a:extLst>
-          </p:cNvPr>
-          <p:cNvSpPr>
-            <a:spLocks xmlns:a="http://schemas.openxmlformats.org/drawingml/2006/main" noGrp="1"/>
-          </p:cNvSpPr>
-          <p:nvPr/>
-        </p:nvSpPr>
-        <p:spPr>
-          <a:xfrm xmlns:a="http://schemas.openxmlformats.org/drawingml/2006/main">
-            <a:off x="5143500" y="3600450"/>
-            <a:ext cx="1543050" cy="381000"/>
-          </a:xfrm>
-          <a:prstGeom xmlns:a="http://schemas.openxmlformats.org/drawingml/2006/main" prst="rect">
-            <a:avLst/>
-          </a:prstGeom>
-          <a:noFill xmlns:a="http://schemas.openxmlformats.org/drawingml/2006/main"/>
-          <a:ln xmlns:a="http://schemas.openxmlformats.org/drawingml/2006/main" w="0">
-            <a:noFill/>
-            <a:prstDash val="solid"/>
-          </a:ln>
-        </p:spPr>
-        <p:txBody>
-          <a:bodyPr xmlns:a="http://schemas.openxmlformats.org/drawingml/2006/main" wrap="square" lIns="0" tIns="0" rIns="0" bIns="0" anchor="t">
-            <a:normAutofit fontScale="100000"/>
-          </a:bodyPr>
-          <a:lstStyle xmlns:a="http://schemas.openxmlformats.org/drawingml/2006/main"/>
-          <a:p xmlns:a="http://schemas.openxmlformats.org/drawingml/2006/main">
-            <a:pPr algn="l">
-              <a:buNone/>
-              <a:defRPr sz="1125" b="0">
-                <a:solidFill>
-                  <a:srgbClr val="5C6570"/>
-                </a:solidFill>
-                <a:latin typeface="Noto Sans TC"/>
-                <a:ea typeface="Noto Sans TC"/>
-                <a:cs typeface="Noto Sans TC"/>
-              </a:defRPr>
-            </a:pPr>
-            <a:r>
-              <a:rPr sz="1125" b="0">
-                <a:solidFill>
-                  <a:srgbClr val="5C6570"/>
-                </a:solidFill>
-                <a:latin typeface="Noto Sans TC"/>
-                <a:ea typeface="Noto Sans TC"/>
-                <a:cs typeface="Noto Sans TC"/>
-              </a:rPr>
-              <a:t>Work Level · slices · JIT</a:t>
-            </a:r>
-          </a:p>
-        </p:txBody>
-      </p:sp>
-      <p:sp>
-        <p:nvSpPr>
-          <p:cNvPr id="23" name="">
-            <a:extLst xmlns:a="http://schemas.openxmlformats.org/drawingml/2006/main">
-              <a:ext uri="{FF2B5EF4-FFF2-40B4-BE49-F238E27FC236}">
-                <a16:creationId xmlns:a16="http://schemas.microsoft.com/office/drawing/2014/main" id="{A402EEDE-92F8-4110-AC0D-88768D979A5E}"/>
-              </a:ext>
-            </a:extLst>
-          </p:cNvPr>
-          <p:cNvSpPr>
-            <a:spLocks xmlns:a="http://schemas.openxmlformats.org/drawingml/2006/main" noGrp="1"/>
-          </p:cNvSpPr>
-          <p:nvPr/>
-        </p:nvSpPr>
-        <p:spPr>
-          <a:xfrm xmlns:a="http://schemas.openxmlformats.org/drawingml/2006/main">
-            <a:off x="7258050" y="2638425"/>
-            <a:ext cx="1885950" cy="1466850"/>
-          </a:xfrm>
-          <a:prstGeom xmlns:a="http://schemas.openxmlformats.org/drawingml/2006/main" prst="rect">
-            <a:avLst/>
-          </a:prstGeom>
-          <a:solidFill xmlns:a="http://schemas.openxmlformats.org/drawingml/2006/main">
-            <a:srgbClr val="F1F2F3"/>
-          </a:solidFill>
-          <a:ln xmlns:a="http://schemas.openxmlformats.org/drawingml/2006/main" w="0">
-            <a:noFill/>
-            <a:prstDash val="solid"/>
-          </a:ln>
-        </p:spPr>
-      </p:sp>
-      <p:sp>
-        <p:nvSpPr>
-          <p:cNvPr id="24" name="">
-            <a:extLst xmlns:a="http://schemas.openxmlformats.org/drawingml/2006/main">
-              <a:ext uri="{FF2B5EF4-FFF2-40B4-BE49-F238E27FC236}">
-                <a16:creationId xmlns:a16="http://schemas.microsoft.com/office/drawing/2014/main" id="{D1544BAB-191C-4921-ADD4-E5AEC486C715}"/>
-              </a:ext>
-            </a:extLst>
-          </p:cNvPr>
-          <p:cNvSpPr>
-            <a:spLocks xmlns:a="http://schemas.openxmlformats.org/drawingml/2006/main" noGrp="1"/>
-          </p:cNvSpPr>
-          <p:nvPr/>
-        </p:nvSpPr>
-        <p:spPr>
-          <a:xfrm xmlns:a="http://schemas.openxmlformats.org/drawingml/2006/main">
-            <a:off x="7429500" y="2800350"/>
-            <a:ext cx="381000" cy="285750"/>
-          </a:xfrm>
-          <a:prstGeom xmlns:a="http://schemas.openxmlformats.org/drawingml/2006/main" prst="rect">
-            <a:avLst/>
-          </a:prstGeom>
-          <a:noFill xmlns:a="http://schemas.openxmlformats.org/drawingml/2006/main"/>
-          <a:ln xmlns:a="http://schemas.openxmlformats.org/drawingml/2006/main" w="0">
-            <a:noFill/>
-            <a:prstDash val="solid"/>
-          </a:ln>
-        </p:spPr>
-        <p:txBody>
-          <a:bodyPr xmlns:a="http://schemas.openxmlformats.org/drawingml/2006/main" wrap="square" lIns="0" tIns="0" rIns="0" bIns="0" anchor="t">
-            <a:normAutofit fontScale="100000"/>
-          </a:bodyPr>
-          <a:lstStyle xmlns:a="http://schemas.openxmlformats.org/drawingml/2006/main"/>
-          <a:p xmlns:a="http://schemas.openxmlformats.org/drawingml/2006/main">
-            <a:pPr algn="l">
-              <a:buNone/>
-              <a:defRPr sz="1650" b="1">
-                <a:solidFill>
-                  <a:srgbClr val="2478E5"/>
-                </a:solidFill>
-                <a:latin typeface="Noto Sans TC"/>
-                <a:ea typeface="Noto Sans TC"/>
-                <a:cs typeface="Noto Sans TC"/>
-              </a:defRPr>
-            </a:pPr>
-            <a:r>
-              <a:rPr sz="1650" b="1">
-                <a:solidFill>
-                  <a:srgbClr val="2478E5"/>
-                </a:solidFill>
-                <a:latin typeface="Noto Sans TC"/>
-                <a:ea typeface="Noto Sans TC"/>
-                <a:cs typeface="Noto Sans TC"/>
-              </a:rPr>
-              <a:t>4</a:t>
-            </a:r>
-          </a:p>
-        </p:txBody>
-      </p:sp>
-      <p:sp>
-        <p:nvSpPr>
-          <p:cNvPr id="25" name="">
-            <a:extLst xmlns:a="http://schemas.openxmlformats.org/drawingml/2006/main">
-              <a:ext uri="{FF2B5EF4-FFF2-40B4-BE49-F238E27FC236}">
-                <a16:creationId xmlns:a16="http://schemas.microsoft.com/office/drawing/2014/main" id="{603E68D6-5720-449B-B45F-C9C1FA9E613E}"/>
-              </a:ext>
-            </a:extLst>
-          </p:cNvPr>
-          <p:cNvSpPr>
-            <a:spLocks xmlns:a="http://schemas.openxmlformats.org/drawingml/2006/main" noGrp="1"/>
-          </p:cNvSpPr>
-          <p:nvPr/>
-        </p:nvSpPr>
-        <p:spPr>
-          <a:xfrm xmlns:a="http://schemas.openxmlformats.org/drawingml/2006/main">
-            <a:off x="7429500" y="3171825"/>
-            <a:ext cx="1543050" cy="304800"/>
-          </a:xfrm>
-          <a:prstGeom xmlns:a="http://schemas.openxmlformats.org/drawingml/2006/main" prst="rect">
-            <a:avLst/>
-          </a:prstGeom>
-          <a:noFill xmlns:a="http://schemas.openxmlformats.org/drawingml/2006/main"/>
-          <a:ln xmlns:a="http://schemas.openxmlformats.org/drawingml/2006/main" w="0">
-            <a:noFill/>
-            <a:prstDash val="solid"/>
-          </a:ln>
-        </p:spPr>
-        <p:txBody>
-          <a:bodyPr xmlns:a="http://schemas.openxmlformats.org/drawingml/2006/main" wrap="square" lIns="0" tIns="0" rIns="0" bIns="0" anchor="t">
-            <a:normAutofit fontScale="100000"/>
-          </a:bodyPr>
-          <a:lstStyle xmlns:a="http://schemas.openxmlformats.org/drawingml/2006/main"/>
-          <a:p xmlns:a="http://schemas.openxmlformats.org/drawingml/2006/main">
-            <a:pPr algn="l">
-              <a:buNone/>
-              <a:defRPr sz="1725" b="1">
-                <a:solidFill>
-                  <a:srgbClr val="111111"/>
-                </a:solidFill>
-                <a:latin typeface="Noto Sans TC"/>
-                <a:ea typeface="Noto Sans TC"/>
-                <a:cs typeface="Noto Sans TC"/>
-              </a:defRPr>
-            </a:pPr>
-            <a:r>
-              <a:rPr sz="1725" b="1">
-                <a:solidFill>
-                  <a:srgbClr val="111111"/>
-                </a:solidFill>
-                <a:latin typeface="Noto Sans TC"/>
-                <a:ea typeface="Noto Sans TC"/>
-                <a:cs typeface="Noto Sans TC"/>
-              </a:rPr>
-              <a:t>Implement</a:t>
-            </a:r>
-          </a:p>
-        </p:txBody>
-      </p:sp>
-      <p:sp>
-        <p:nvSpPr>
-          <p:cNvPr id="26" name="">
-            <a:extLst xmlns:a="http://schemas.openxmlformats.org/drawingml/2006/main">
-              <a:ext uri="{FF2B5EF4-FFF2-40B4-BE49-F238E27FC236}">
-                <a16:creationId xmlns:a16="http://schemas.microsoft.com/office/drawing/2014/main" id="{D6623CAE-065D-4B9B-AC43-4A041DCDB67F}"/>
-              </a:ext>
-            </a:extLst>
-          </p:cNvPr>
-          <p:cNvSpPr>
-            <a:spLocks xmlns:a="http://schemas.openxmlformats.org/drawingml/2006/main" noGrp="1"/>
-          </p:cNvSpPr>
-          <p:nvPr/>
-        </p:nvSpPr>
-        <p:spPr>
-          <a:xfrm xmlns:a="http://schemas.openxmlformats.org/drawingml/2006/main">
-            <a:off x="7429500" y="3600450"/>
-            <a:ext cx="1543050" cy="381000"/>
-          </a:xfrm>
-          <a:prstGeom xmlns:a="http://schemas.openxmlformats.org/drawingml/2006/main" prst="rect">
-            <a:avLst/>
-          </a:prstGeom>
-          <a:noFill xmlns:a="http://schemas.openxmlformats.org/drawingml/2006/main"/>
-          <a:ln xmlns:a="http://schemas.openxmlformats.org/drawingml/2006/main" w="0">
-            <a:noFill/>
-            <a:prstDash val="solid"/>
-          </a:ln>
-        </p:spPr>
-        <p:txBody>
-          <a:bodyPr xmlns:a="http://schemas.openxmlformats.org/drawingml/2006/main" wrap="square" lIns="0" tIns="0" rIns="0" bIns="0" anchor="t">
-            <a:normAutofit fontScale="100000"/>
-          </a:bodyPr>
-          <a:lstStyle xmlns:a="http://schemas.openxmlformats.org/drawingml/2006/main"/>
-          <a:p xmlns:a="http://schemas.openxmlformats.org/drawingml/2006/main">
-            <a:pPr algn="l">
-              <a:buNone/>
-              <a:defRPr sz="1125" b="0">
-                <a:solidFill>
-                  <a:srgbClr val="5C6570"/>
-                </a:solidFill>
-                <a:latin typeface="Noto Sans TC"/>
-                <a:ea typeface="Noto Sans TC"/>
-                <a:cs typeface="Noto Sans TC"/>
-              </a:defRPr>
-            </a:pPr>
-            <a:r>
-              <a:rPr sz="1125" b="0">
-                <a:solidFill>
-                  <a:srgbClr val="5C6570"/>
-                </a:solidFill>
-                <a:latin typeface="Noto Sans TC"/>
-                <a:ea typeface="Noto Sans TC"/>
-                <a:cs typeface="Noto Sans TC"/>
-              </a:rPr>
-              <a:t>Default skill · TDD · review</a:t>
-            </a:r>
-          </a:p>
-        </p:txBody>
-      </p:sp>
-      <p:sp>
-        <p:nvSpPr>
-          <p:cNvPr id="27" name="">
-            <a:extLst xmlns:a="http://schemas.openxmlformats.org/drawingml/2006/main">
-              <a:ext uri="{FF2B5EF4-FFF2-40B4-BE49-F238E27FC236}">
-                <a16:creationId xmlns:a16="http://schemas.microsoft.com/office/drawing/2014/main" id="{8642A8C1-FBF5-4915-B9DE-02CA8C8D9000}"/>
-              </a:ext>
-            </a:extLst>
-          </p:cNvPr>
-          <p:cNvSpPr>
-            <a:spLocks xmlns:a="http://schemas.openxmlformats.org/drawingml/2006/main" noGrp="1"/>
-          </p:cNvSpPr>
-          <p:nvPr/>
-        </p:nvSpPr>
-        <p:spPr>
-          <a:xfrm xmlns:a="http://schemas.openxmlformats.org/drawingml/2006/main">
-            <a:off x="9544050" y="2638425"/>
-            <a:ext cx="1885950" cy="1466850"/>
-          </a:xfrm>
-          <a:prstGeom xmlns:a="http://schemas.openxmlformats.org/drawingml/2006/main" prst="rect">
-            <a:avLst/>
-          </a:prstGeom>
-          <a:solidFill xmlns:a="http://schemas.openxmlformats.org/drawingml/2006/main">
-            <a:srgbClr val="F1F2F3"/>
-          </a:solidFill>
-          <a:ln xmlns:a="http://schemas.openxmlformats.org/drawingml/2006/main" w="0">
-            <a:noFill/>
-            <a:prstDash val="solid"/>
-          </a:ln>
-        </p:spPr>
-      </p:sp>
-      <p:sp>
-        <p:nvSpPr>
-          <p:cNvPr id="28" name="">
-            <a:extLst xmlns:a="http://schemas.openxmlformats.org/drawingml/2006/main">
-              <a:ext uri="{FF2B5EF4-FFF2-40B4-BE49-F238E27FC236}">
-                <a16:creationId xmlns:a16="http://schemas.microsoft.com/office/drawing/2014/main" id="{DD049B17-7F99-4567-ACF7-0B63D88270D8}"/>
-              </a:ext>
-            </a:extLst>
-          </p:cNvPr>
-          <p:cNvSpPr>
-            <a:spLocks xmlns:a="http://schemas.openxmlformats.org/drawingml/2006/main" noGrp="1"/>
-          </p:cNvSpPr>
-          <p:nvPr/>
-        </p:nvSpPr>
-        <p:spPr>
-          <a:xfrm xmlns:a="http://schemas.openxmlformats.org/drawingml/2006/main">
-            <a:off x="9715500" y="2800350"/>
-            <a:ext cx="381000" cy="285750"/>
-          </a:xfrm>
-          <a:prstGeom xmlns:a="http://schemas.openxmlformats.org/drawingml/2006/main" prst="rect">
-            <a:avLst/>
-          </a:prstGeom>
-          <a:noFill xmlns:a="http://schemas.openxmlformats.org/drawingml/2006/main"/>
-          <a:ln xmlns:a="http://schemas.openxmlformats.org/drawingml/2006/main" w="0">
-            <a:noFill/>
-            <a:prstDash val="solid"/>
-          </a:ln>
-        </p:spPr>
-        <p:txBody>
-          <a:bodyPr xmlns:a="http://schemas.openxmlformats.org/drawingml/2006/main" wrap="square" lIns="0" tIns="0" rIns="0" bIns="0" anchor="t">
-            <a:normAutofit fontScale="100000"/>
-          </a:bodyPr>
-          <a:lstStyle xmlns:a="http://schemas.openxmlformats.org/drawingml/2006/main"/>
-          <a:p xmlns:a="http://schemas.openxmlformats.org/drawingml/2006/main">
-            <a:pPr algn="l">
-              <a:buNone/>
-              <a:defRPr sz="1650" b="1">
-                <a:solidFill>
-                  <a:srgbClr val="2478E5"/>
-                </a:solidFill>
-                <a:latin typeface="Noto Sans TC"/>
-                <a:ea typeface="Noto Sans TC"/>
-                <a:cs typeface="Noto Sans TC"/>
-              </a:defRPr>
-            </a:pPr>
-            <a:r>
-              <a:rPr sz="1650" b="1">
-                <a:solidFill>
-                  <a:srgbClr val="2478E5"/>
-                </a:solidFill>
-                <a:latin typeface="Noto Sans TC"/>
-                <a:ea typeface="Noto Sans TC"/>
-                <a:cs typeface="Noto Sans TC"/>
-              </a:rPr>
-              <a:t>5</a:t>
-            </a:r>
-          </a:p>
-        </p:txBody>
-      </p:sp>
-      <p:sp>
-        <p:nvSpPr>
-          <p:cNvPr id="29" name="">
-            <a:extLst xmlns:a="http://schemas.openxmlformats.org/drawingml/2006/main">
-              <a:ext uri="{FF2B5EF4-FFF2-40B4-BE49-F238E27FC236}">
-                <a16:creationId xmlns:a16="http://schemas.microsoft.com/office/drawing/2014/main" id="{F49DD13C-9242-4308-A97E-AF0E92CE49F5}"/>
-              </a:ext>
-            </a:extLst>
-          </p:cNvPr>
-          <p:cNvSpPr>
-            <a:spLocks xmlns:a="http://schemas.openxmlformats.org/drawingml/2006/main" noGrp="1"/>
-          </p:cNvSpPr>
-          <p:nvPr/>
-        </p:nvSpPr>
-        <p:spPr>
-          <a:xfrm xmlns:a="http://schemas.openxmlformats.org/drawingml/2006/main">
-            <a:off x="9715500" y="3171825"/>
-            <a:ext cx="1543050" cy="304800"/>
-          </a:xfrm>
-          <a:prstGeom xmlns:a="http://schemas.openxmlformats.org/drawingml/2006/main" prst="rect">
-            <a:avLst/>
-          </a:prstGeom>
-          <a:noFill xmlns:a="http://schemas.openxmlformats.org/drawingml/2006/main"/>
-          <a:ln xmlns:a="http://schemas.openxmlformats.org/drawingml/2006/main" w="0">
-            <a:noFill/>
-            <a:prstDash val="solid"/>
-          </a:ln>
-        </p:spPr>
-        <p:txBody>
-          <a:bodyPr xmlns:a="http://schemas.openxmlformats.org/drawingml/2006/main" wrap="square" lIns="0" tIns="0" rIns="0" bIns="0" anchor="t">
-            <a:normAutofit fontScale="100000"/>
-          </a:bodyPr>
-          <a:lstStyle xmlns:a="http://schemas.openxmlformats.org/drawingml/2006/main"/>
-          <a:p xmlns:a="http://schemas.openxmlformats.org/drawingml/2006/main">
-            <a:pPr algn="l">
-              <a:buNone/>
-              <a:defRPr sz="1725" b="1">
-                <a:solidFill>
-                  <a:srgbClr val="111111"/>
-                </a:solidFill>
-                <a:latin typeface="Noto Sans TC"/>
-                <a:ea typeface="Noto Sans TC"/>
-                <a:cs typeface="Noto Sans TC"/>
-              </a:defRPr>
-            </a:pPr>
-            <a:r>
-              <a:rPr sz="1725" b="1">
-                <a:solidFill>
-                  <a:srgbClr val="111111"/>
-                </a:solidFill>
-                <a:latin typeface="Noto Sans TC"/>
-                <a:ea typeface="Noto Sans TC"/>
-                <a:cs typeface="Noto Sans TC"/>
-              </a:rPr>
-              <a:t>Validate</a:t>
-            </a:r>
-          </a:p>
-        </p:txBody>
-      </p:sp>
-      <p:sp>
-        <p:nvSpPr>
-          <p:cNvPr id="30" name="">
-            <a:extLst xmlns:a="http://schemas.openxmlformats.org/drawingml/2006/main">
-              <a:ext uri="{FF2B5EF4-FFF2-40B4-BE49-F238E27FC236}">
-                <a16:creationId xmlns:a16="http://schemas.microsoft.com/office/drawing/2014/main" id="{96901030-E5E2-44EF-B20F-A4855CE89D32}"/>
-              </a:ext>
-            </a:extLst>
-          </p:cNvPr>
-          <p:cNvSpPr>
-            <a:spLocks xmlns:a="http://schemas.openxmlformats.org/drawingml/2006/main" noGrp="1"/>
-          </p:cNvSpPr>
-          <p:nvPr/>
-        </p:nvSpPr>
-        <p:spPr>
-          <a:xfrm xmlns:a="http://schemas.openxmlformats.org/drawingml/2006/main">
-            <a:off x="9715500" y="3600450"/>
-            <a:ext cx="1543050" cy="381000"/>
-          </a:xfrm>
-          <a:prstGeom xmlns:a="http://schemas.openxmlformats.org/drawingml/2006/main" prst="rect">
-            <a:avLst/>
-          </a:prstGeom>
-          <a:noFill xmlns:a="http://schemas.openxmlformats.org/drawingml/2006/main"/>
-          <a:ln xmlns:a="http://schemas.openxmlformats.org/drawingml/2006/main" w="0">
-            <a:noFill/>
-            <a:prstDash val="solid"/>
-          </a:ln>
-        </p:spPr>
-        <p:txBody>
-          <a:bodyPr xmlns:a="http://schemas.openxmlformats.org/drawingml/2006/main" wrap="square" lIns="0" tIns="0" rIns="0" bIns="0" anchor="t">
-            <a:normAutofit fontScale="100000"/>
-          </a:bodyPr>
-          <a:lstStyle xmlns:a="http://schemas.openxmlformats.org/drawingml/2006/main"/>
-          <a:p xmlns:a="http://schemas.openxmlformats.org/drawingml/2006/main">
-            <a:pPr algn="l">
-              <a:buNone/>
-              <a:defRPr sz="1125" b="0">
-                <a:solidFill>
-                  <a:srgbClr val="5C6570"/>
-                </a:solidFill>
-                <a:latin typeface="Noto Sans TC"/>
-                <a:ea typeface="Noto Sans TC"/>
-                <a:cs typeface="Noto Sans TC"/>
-              </a:defRPr>
-            </a:pPr>
-            <a:r>
-              <a:rPr sz="1125" b="0">
-                <a:solidFill>
-                  <a:srgbClr val="5C6570"/>
-                </a:solidFill>
-                <a:latin typeface="Noto Sans TC"/>
-                <a:ea typeface="Noto Sans TC"/>
-                <a:cs typeface="Noto Sans TC"/>
-              </a:rPr>
-              <a:t>Acceptance · risk · evidence</a:t>
-            </a:r>
-          </a:p>
-        </p:txBody>
-      </p:sp>
-      <p:cxnSp>
-        <p:nvCxnSpPr>
-          <p:cNvPr id="655" name=""/>
-          <p:cNvCxnSpPr/>
-          <p:nvPr/>
-        </p:nvCxnSpPr>
-        <p:spPr>
-          <a:xfrm xmlns:a="http://schemas.openxmlformats.org/drawingml/2006/main">
-            <a:off x="10487025" y="4267200"/>
-            <a:ext cx="0" cy="552450"/>
-          </a:xfrm>
-          <a:prstGeom xmlns:a="http://schemas.openxmlformats.org/drawingml/2006/main" prst="straightConnector1">
-            <a:avLst/>
-          </a:prstGeom>
-          <a:ln xmlns:a="http://schemas.openxmlformats.org/drawingml/2006/main" w="19050">
-            <a:solidFill>
-              <a:srgbClr val="2478E5"/>
-            </a:solidFill>
-            <a:prstDash val="solid"/>
-          </a:ln>
-        </p:spPr>
-      </p:cxnSp>
-      <p:sp>
-        <p:nvSpPr>
-          <p:cNvPr id="32" name="">
-            <a:extLst xmlns:a="http://schemas.openxmlformats.org/drawingml/2006/main">
-              <a:ext uri="{FF2B5EF4-FFF2-40B4-BE49-F238E27FC236}">
-                <a16:creationId xmlns:a16="http://schemas.microsoft.com/office/drawing/2014/main" id="{00076C5B-26B1-4CFF-8876-A40E9EA9AE86}"/>
-              </a:ext>
-            </a:extLst>
-          </p:cNvPr>
-          <p:cNvSpPr>
-            <a:spLocks xmlns:a="http://schemas.openxmlformats.org/drawingml/2006/main" noGrp="1"/>
-          </p:cNvSpPr>
-          <p:nvPr/>
-        </p:nvSpPr>
-        <p:spPr>
-          <a:xfrm xmlns:a="http://schemas.openxmlformats.org/drawingml/2006/main">
-            <a:off x="7258050" y="4838700"/>
-            <a:ext cx="4171950" cy="704850"/>
-          </a:xfrm>
-          <a:prstGeom xmlns:a="http://schemas.openxmlformats.org/drawingml/2006/main" prst="rect">
-            <a:avLst/>
-          </a:prstGeom>
-          <a:solidFill xmlns:a="http://schemas.openxmlformats.org/drawingml/2006/main">
-            <a:srgbClr val="6DCBF4"/>
-          </a:solidFill>
-          <a:ln xmlns:a="http://schemas.openxmlformats.org/drawingml/2006/main" w="0">
-            <a:noFill/>
-            <a:prstDash val="solid"/>
-          </a:ln>
-        </p:spPr>
-      </p:sp>
-      <p:sp>
-        <p:nvSpPr>
-          <p:cNvPr id="33" name="">
-            <a:extLst xmlns:a="http://schemas.openxmlformats.org/drawingml/2006/main">
-              <a:ext uri="{FF2B5EF4-FFF2-40B4-BE49-F238E27FC236}">
-                <a16:creationId xmlns:a16="http://schemas.microsoft.com/office/drawing/2014/main" id="{EBD2EE01-7DD3-4D89-B931-BA839CE076A0}"/>
-              </a:ext>
-            </a:extLst>
-          </p:cNvPr>
-          <p:cNvSpPr>
-            <a:spLocks xmlns:a="http://schemas.openxmlformats.org/drawingml/2006/main" noGrp="1"/>
-          </p:cNvSpPr>
-          <p:nvPr/>
-        </p:nvSpPr>
-        <p:spPr>
-          <a:xfrm xmlns:a="http://schemas.openxmlformats.org/drawingml/2006/main">
-            <a:off x="7486650" y="5000625"/>
-            <a:ext cx="1790700" cy="266700"/>
-          </a:xfrm>
-          <a:prstGeom xmlns:a="http://schemas.openxmlformats.org/drawingml/2006/main" prst="rect">
-            <a:avLst/>
-          </a:prstGeom>
-          <a:noFill xmlns:a="http://schemas.openxmlformats.org/drawingml/2006/main"/>
-          <a:ln xmlns:a="http://schemas.openxmlformats.org/drawingml/2006/main" w="0">
-            <a:noFill/>
-            <a:prstDash val="solid"/>
-          </a:ln>
-        </p:spPr>
-        <p:txBody>
-          <a:bodyPr xmlns:a="http://schemas.openxmlformats.org/drawingml/2006/main" wrap="square" lIns="0" tIns="0" rIns="0" bIns="0" anchor="t">
-            <a:normAutofit fontScale="100000"/>
-          </a:bodyPr>
-          <a:lstStyle xmlns:a="http://schemas.openxmlformats.org/drawingml/2006/main"/>
-          <a:p xmlns:a="http://schemas.openxmlformats.org/drawingml/2006/main">
-            <a:pPr algn="l">
-              <a:buNone/>
-              <a:defRPr sz="1650" b="1">
-                <a:solidFill>
-                  <a:srgbClr val="173B57"/>
-                </a:solidFill>
-                <a:latin typeface="Noto Sans TC"/>
-                <a:ea typeface="Noto Sans TC"/>
-                <a:cs typeface="Noto Sans TC"/>
-              </a:defRPr>
-            </a:pPr>
-            <a:r>
-              <a:rPr sz="1650" b="1">
-                <a:solidFill>
-                  <a:srgbClr val="173B57"/>
-                </a:solidFill>
-                <a:latin typeface="Noto Sans TC"/>
-                <a:ea typeface="Noto Sans TC"/>
-                <a:cs typeface="Noto Sans TC"/>
-              </a:rPr>
-              <a:t>不同大小</a:t>
-            </a:r>
-          </a:p>
-        </p:txBody>
-      </p:sp>
-      <p:sp>
-        <p:nvSpPr>
-          <p:cNvPr id="34" name="">
-            <a:extLst xmlns:a="http://schemas.openxmlformats.org/drawingml/2006/main">
-              <a:ext uri="{FF2B5EF4-FFF2-40B4-BE49-F238E27FC236}">
-                <a16:creationId xmlns:a16="http://schemas.microsoft.com/office/drawing/2014/main" id="{E8A5AEA1-A183-4F88-B87F-196210B37322}"/>
-              </a:ext>
-            </a:extLst>
-          </p:cNvPr>
-          <p:cNvSpPr>
-            <a:spLocks xmlns:a="http://schemas.openxmlformats.org/drawingml/2006/main" noGrp="1"/>
-          </p:cNvSpPr>
-          <p:nvPr/>
-        </p:nvSpPr>
-        <p:spPr>
-          <a:xfrm xmlns:a="http://schemas.openxmlformats.org/drawingml/2006/main">
-            <a:off x="9353550" y="5019675"/>
-            <a:ext cx="1847850" cy="247650"/>
-          </a:xfrm>
-          <a:prstGeom xmlns:a="http://schemas.openxmlformats.org/drawingml/2006/main" prst="rect">
-            <a:avLst/>
-          </a:prstGeom>
-          <a:noFill xmlns:a="http://schemas.openxmlformats.org/drawingml/2006/main"/>
-          <a:ln xmlns:a="http://schemas.openxmlformats.org/drawingml/2006/main" w="0">
-            <a:noFill/>
-            <a:prstDash val="solid"/>
-          </a:ln>
-        </p:spPr>
-        <p:txBody>
-          <a:bodyPr xmlns:a="http://schemas.openxmlformats.org/drawingml/2006/main" wrap="square" lIns="0" tIns="0" rIns="0" bIns="0" anchor="t">
-            <a:normAutofit fontScale="100000"/>
-          </a:bodyPr>
-          <a:lstStyle xmlns:a="http://schemas.openxmlformats.org/drawingml/2006/main"/>
-          <a:p xmlns:a="http://schemas.openxmlformats.org/drawingml/2006/main">
-            <a:pPr algn="l">
-              <a:buNone/>
-              <a:defRPr sz="1200" b="0">
-                <a:solidFill>
-                  <a:srgbClr val="173B57"/>
-                </a:solidFill>
-                <a:latin typeface="Noto Sans TC"/>
-                <a:ea typeface="Noto Sans TC"/>
-                <a:cs typeface="Noto Sans TC"/>
-              </a:defRPr>
-            </a:pPr>
-            <a:r>
-              <a:rPr sz="1200" b="0">
-                <a:solidFill>
-                  <a:srgbClr val="173B57"/>
-                </a:solidFill>
-                <a:latin typeface="Noto Sans TC"/>
-                <a:ea typeface="Noto Sans TC"/>
-                <a:cs typeface="Noto Sans TC"/>
-              </a:rPr>
-              <a:t>同一流程 · 深度不同</a:t>
-            </a:r>
-          </a:p>
-        </p:txBody>
-      </p:sp>
-      <p:sp>
-        <p:nvSpPr>
-          <p:cNvPr id="35" name="">
-            <a:extLst xmlns:a="http://schemas.openxmlformats.org/drawingml/2006/main">
-              <a:ext uri="{FF2B5EF4-FFF2-40B4-BE49-F238E27FC236}">
-                <a16:creationId xmlns:a16="http://schemas.microsoft.com/office/drawing/2014/main" id="{736A3A2F-C0C8-494A-B190-E7457D7BAB16}"/>
-              </a:ext>
-            </a:extLst>
-          </p:cNvPr>
-          <p:cNvSpPr>
-            <a:spLocks xmlns:a="http://schemas.openxmlformats.org/drawingml/2006/main" noGrp="1"/>
-          </p:cNvSpPr>
-          <p:nvPr/>
-        </p:nvSpPr>
-        <p:spPr>
-          <a:xfrm xmlns:a="http://schemas.openxmlformats.org/drawingml/2006/main">
-            <a:off x="400050" y="5810250"/>
-            <a:ext cx="8096250" cy="238125"/>
-          </a:xfrm>
-          <a:prstGeom xmlns:a="http://schemas.openxmlformats.org/drawingml/2006/main" prst="rect">
-            <a:avLst/>
-          </a:prstGeom>
-          <a:noFill xmlns:a="http://schemas.openxmlformats.org/drawingml/2006/main"/>
-          <a:ln xmlns:a="http://schemas.openxmlformats.org/drawingml/2006/main" w="0">
-            <a:noFill/>
-            <a:prstDash val="solid"/>
-          </a:ln>
-        </p:spPr>
-        <p:txBody>
-          <a:bodyPr xmlns:a="http://schemas.openxmlformats.org/drawingml/2006/main" wrap="square" lIns="0" tIns="0" rIns="0" bIns="0" anchor="t">
-            <a:normAutofit fontScale="100000"/>
-          </a:bodyPr>
-          <a:lstStyle xmlns:a="http://schemas.openxmlformats.org/drawingml/2006/main"/>
-          <a:p xmlns:a="http://schemas.openxmlformats.org/drawingml/2006/main">
-            <a:pPr algn="l">
-              <a:buNone/>
-              <a:defRPr sz="1125" b="0">
-                <a:solidFill>
-                  <a:srgbClr val="5C6570"/>
-                </a:solidFill>
-                <a:latin typeface="Noto Sans TC"/>
-                <a:ea typeface="Noto Sans TC"/>
-                <a:cs typeface="Noto Sans TC"/>
-              </a:defRPr>
-            </a:pPr>
-            <a:r>
-              <a:rPr sz="1125" b="0">
-                <a:solidFill>
-                  <a:srgbClr val="5C6570"/>
-                </a:solidFill>
-                <a:latin typeface="Noto Sans TC"/>
-                <a:ea typeface="Noto Sans TC"/>
-                <a:cs typeface="Noto Sans TC"/>
-              </a:rPr>
-              <a:t>同一 Golden Flow 適用 P3→P0；Golden defaults 經 10+ actual pilots 淬煉，可直接使用或採 approved equivalent。</a:t>
+              <a:defRPr sz="1425" b="1">
+                <a:solidFill>
+                  <a:srgbClr val="111111"/>
+                </a:solidFill>
+                <a:latin typeface="Noto Sans TC"/>
+                <a:ea typeface="Noto Sans TC"/>
+                <a:cs typeface="Noto Sans TC"/>
+              </a:defRPr>
+            </a:pPr>
+            <a:r>
+              <a:rPr sz="1600" b="1">
+                <a:solidFill>
+                  <a:srgbClr val="151515"/>
+                </a:solidFill>
+                <a:latin typeface="Noto Sans TC"/>
+                <a:ea typeface="Noto Sans TC"/>
+                <a:cs typeface="Noto Sans TC"/>
+              </a:rPr>
+              <a:t>TAKEAWAY · AI models 會一直變；human accountability、SSOT、evidence 與 approval 必須持久。</a:t>
             </a:r>
           </a:p>
         </p:txBody>
@@ -4967,7 +4933,7 @@
     </p:spTree>
     <p:extLst>
       <p:ext uri="{BB962C8B-B14F-4D97-AF65-F5344CB8AC3E}">
-        <p14:creationId xmlns:p14="http://schemas.microsoft.com/office/powerpoint/2010/main" val="593617219"/>
+        <p14:creationId xmlns:p14="http://schemas.microsoft.com/office/powerpoint/2010/main" val="534048330"/>
       </p:ext>
     </p:extLst>
   </p:cSld>
@@ -5054,7 +5020,7 @@
       </p:sp>
       <p:cxnSp>
         <p:nvCxnSpPr>
-          <p:cNvPr id="626" name=""/>
+          <p:cNvPr id="812" name=""/>
           <p:cNvCxnSpPr/>
           <p:nvPr/>
         </p:nvCxnSpPr>
@@ -5284,7 +5250,7 @@
       </p:sp>
       <p:cxnSp>
         <p:nvCxnSpPr>
-          <p:cNvPr id="631" name=""/>
+          <p:cNvPr id="817" name=""/>
           <p:cNvCxnSpPr/>
           <p:nvPr/>
         </p:nvCxnSpPr>
@@ -5306,7 +5272,7 @@
       </p:cxnSp>
       <p:cxnSp>
         <p:nvCxnSpPr>
-          <p:cNvPr id="632" name=""/>
+          <p:cNvPr id="818" name=""/>
           <p:cNvCxnSpPr/>
           <p:nvPr/>
         </p:nvCxnSpPr>
@@ -5328,7 +5294,7 @@
       </p:cxnSp>
       <p:cxnSp>
         <p:nvCxnSpPr>
-          <p:cNvPr id="633" name=""/>
+          <p:cNvPr id="819" name=""/>
           <p:cNvCxnSpPr/>
           <p:nvPr/>
         </p:nvCxnSpPr>
@@ -5350,7 +5316,7 @@
       </p:cxnSp>
       <p:cxnSp>
         <p:nvCxnSpPr>
-          <p:cNvPr id="634" name=""/>
+          <p:cNvPr id="820" name=""/>
           <p:cNvCxnSpPr/>
           <p:nvPr/>
         </p:nvCxnSpPr>
@@ -6412,7 +6378,7 @@
       </p:sp>
       <p:cxnSp>
         <p:nvCxnSpPr>
-          <p:cNvPr id="655" name=""/>
+          <p:cNvPr id="841" name=""/>
           <p:cNvCxnSpPr/>
           <p:nvPr/>
         </p:nvCxnSpPr>
@@ -6730,7 +6696,7 @@
       </p:sp>
       <p:cxnSp>
         <p:nvCxnSpPr>
-          <p:cNvPr id="154" name=""/>
+          <p:cNvPr id="190" name=""/>
           <p:cNvCxnSpPr/>
           <p:nvPr/>
         </p:nvCxnSpPr>
@@ -6811,7 +6777,7 @@
       </p:sp>
       <p:cxnSp>
         <p:nvCxnSpPr>
-          <p:cNvPr id="156" name=""/>
+          <p:cNvPr id="192" name=""/>
           <p:cNvCxnSpPr/>
           <p:nvPr/>
         </p:nvCxnSpPr>
@@ -6833,7 +6799,7 @@
       </p:cxnSp>
       <p:cxnSp>
         <p:nvCxnSpPr>
-          <p:cNvPr id="157" name=""/>
+          <p:cNvPr id="193" name=""/>
           <p:cNvCxnSpPr/>
           <p:nvPr/>
         </p:nvCxnSpPr>
@@ -6855,7 +6821,7 @@
       </p:cxnSp>
       <p:cxnSp>
         <p:nvCxnSpPr>
-          <p:cNvPr id="158" name=""/>
+          <p:cNvPr id="194" name=""/>
           <p:cNvCxnSpPr/>
           <p:nvPr/>
         </p:nvCxnSpPr>
@@ -8594,14 +8560,14 @@
                 <a:ea typeface="Noto Sans TC"/>
                 <a:cs typeface="Noto Sans TC"/>
               </a:rPr>
-              <a:t>P1 Feature 的 Plan：先切 P0，再做 JIT implementation plan</a:t>
+              <a:t>P0 開始實作前，只選一條路：Fast 或 Durable</a:t>
             </a:r>
           </a:p>
         </p:txBody>
       </p:sp>
       <p:cxnSp>
         <p:nvCxnSpPr>
-          <p:cNvPr id="161" name=""/>
+          <p:cNvPr id="203" name=""/>
           <p:cNvCxnSpPr/>
           <p:nvPr/>
         </p:nvCxnSpPr>
@@ -8682,7 +8648,7 @@
       </p:sp>
       <p:cxnSp>
         <p:nvCxnSpPr>
-          <p:cNvPr id="163" name=""/>
+          <p:cNvPr id="205" name=""/>
           <p:cNvCxnSpPr/>
           <p:nvPr/>
         </p:nvCxnSpPr>
@@ -8704,7 +8670,7 @@
       </p:cxnSp>
       <p:cxnSp>
         <p:nvCxnSpPr>
-          <p:cNvPr id="164" name=""/>
+          <p:cNvPr id="206" name=""/>
           <p:cNvCxnSpPr/>
           <p:nvPr/>
         </p:nvCxnSpPr>
@@ -8726,7 +8692,7 @@
       </p:cxnSp>
       <p:cxnSp>
         <p:nvCxnSpPr>
-          <p:cNvPr id="165" name=""/>
+          <p:cNvPr id="207" name=""/>
           <p:cNvCxnSpPr/>
           <p:nvPr/>
         </p:nvCxnSpPr>
@@ -8748,7 +8714,7 @@
       </p:cxnSp>
       <p:cxnSp>
         <p:nvCxnSpPr>
-          <p:cNvPr id="166" name=""/>
+          <p:cNvPr id="208" name=""/>
           <p:cNvCxnSpPr/>
           <p:nvPr/>
         </p:nvCxnSpPr>
@@ -9171,7 +9137,8 @@
                 <a:ea typeface="Noto Sans TC"/>
                 <a:cs typeface="Noto Sans TC"/>
               </a:rPr>
-              <a:t>writing-plans*</a:t>
+              <a:t>Choose route
+Fast / Durable</a:t>
             </a:r>
           </a:p>
         </p:txBody>
@@ -9237,7 +9204,7 @@
         </p:spPr>
         <p:txBody>
           <a:bodyPr xmlns:a="http://schemas.openxmlformats.org/drawingml/2006/main" wrap="square" lIns="0" tIns="0" rIns="0" bIns="0" anchor="ctr">
-            <a:normAutofit fontScale="76023"/>
+            <a:normAutofit fontScale="91366"/>
           </a:bodyPr>
           <a:lstStyle xmlns:a="http://schemas.openxmlformats.org/drawingml/2006/main"/>
           <a:p xmlns:a="http://schemas.openxmlformats.org/drawingml/2006/main">
@@ -9261,7 +9228,7 @@
                 <a:ea typeface="Noto Sans TC"/>
                 <a:cs typeface="Noto Sans TC"/>
               </a:rPr>
-              <a:t>Execution Tasks</a:t>
+              <a:t>Reviewable change</a:t>
             </a:r>
           </a:p>
           <a:p xmlns:a="http://schemas.openxmlformats.org/drawingml/2006/main">
@@ -9285,7 +9252,7 @@
                 <a:ea typeface="Noto Sans TC"/>
                 <a:cs typeface="Noto Sans TC"/>
               </a:rPr>
-              <a:t>files · tests · commands</a:t>
+              <a:t>tests · evidence</a:t>
             </a:r>
           </a:p>
         </p:txBody>
@@ -9375,7 +9342,7 @@
                 <a:ea typeface="Noto Sans TC"/>
                 <a:cs typeface="Noto Sans TC"/>
               </a:rPr>
-              <a:t>DELIVERY DECOMPOSITION</a:t>
+              <a:t>FAST DELIVERY｜需求明確</a:t>
             </a:r>
           </a:p>
         </p:txBody>
@@ -9434,7 +9401,8 @@
                 <a:ea typeface="Noto Sans TC"/>
                 <a:cs typeface="Noto Sans TC"/>
               </a:rPr>
-              <a:t>P1 → P0：每張 ticket 是 narrow but complete tracer bullet。沒有 blocker 的項目形成 execution frontier。</a:t>
+              <a:t>Superpowers 端到端：
+writing-plans*（需要時）→ TDD → review</a:t>
             </a:r>
           </a:p>
         </p:txBody>
@@ -9524,7 +9492,7 @@
                 <a:ea typeface="Noto Sans TC"/>
                 <a:cs typeface="Noto Sans TC"/>
               </a:rPr>
-              <a:t>IMPLEMENTATION PLANNING</a:t>
+              <a:t>DURABLE CHANGE｜需要 durable spec</a:t>
             </a:r>
           </a:p>
         </p:txBody>
@@ -9583,7 +9551,8 @@
                 <a:ea typeface="Noto Sans TC"/>
                 <a:cs typeface="Noto Sans TC"/>
               </a:rPr>
-              <a:t>單一 P0 即將執行且 multi-step / risky / complex 時才產生 exact implementation plan。簡單 P0 可 inline。</a:t>
+              <a:t>OpenSpec tasks.md 是唯一 ledger：
+/opsx:apply → Superpowers per-task TDD</a:t>
             </a:r>
           </a:p>
         </p:txBody>
@@ -9673,7 +9642,7 @@
                 <a:ea typeface="Noto Sans TC"/>
                 <a:cs typeface="Noto Sans TC"/>
               </a:rPr>
-              <a:t>禁止：先替整個 Epic / Feature 建立巨大 implementation plan。Wide refactor 使用 expand → migrate batches → contract。</a:t>
+              <a:t>粗 task 就地展開：1.2 → 1.2.1 / 1.2.2 / 1.2.3　｜　只長子項 = JIT；改變做法 = /opsx:update</a:t>
             </a:r>
           </a:p>
         </p:txBody>
@@ -9732,7 +9701,7 @@
                 <a:ea typeface="Noto Sans TC"/>
                 <a:cs typeface="Noto Sans TC"/>
               </a:rPr>
-              <a:t>藍色 = Golden default skill · writing-plans only when triggered · existing OpenSpec plan stays SSOT</a:t>
+              <a:t>同一 change 只保留一本 ledger；Durable 不使用 writing-plans，也不建立第二份 plan。</a:t>
             </a:r>
           </a:p>
         </p:txBody>
@@ -9827,7 +9796,7 @@
       </p:sp>
       <p:cxnSp>
         <p:nvCxnSpPr>
-          <p:cNvPr id="505" name=""/>
+          <p:cNvPr id="655" name=""/>
           <p:cNvCxnSpPr/>
           <p:nvPr/>
         </p:nvCxnSpPr>
@@ -10219,7 +10188,7 @@
       </p:sp>
       <p:cxnSp>
         <p:nvCxnSpPr>
-          <p:cNvPr id="512" name=""/>
+          <p:cNvPr id="662" name=""/>
           <p:cNvCxnSpPr/>
           <p:nvPr/>
         </p:nvCxnSpPr>
@@ -10615,7 +10584,7 @@
                 <a:ea typeface="Noto Sans TC"/>
                 <a:cs typeface="Noto Sans TC"/>
               </a:rPr>
-              <a:t>Blocked by → execution frontier</a:t>
+              <a:t>Fast｜Superpowers</a:t>
             </a:r>
           </a:p>
           <a:p xmlns:a="http://schemas.openxmlformats.org/drawingml/2006/main">
@@ -10639,7 +10608,7 @@
                 <a:ea typeface="Noto Sans TC"/>
                 <a:cs typeface="Noto Sans TC"/>
               </a:rPr>
-              <a:t>writing-plans → JIT tasks</a:t>
+              <a:t>writing-plans* → TDD</a:t>
             </a:r>
           </a:p>
           <a:p xmlns:a="http://schemas.openxmlformats.org/drawingml/2006/main">
@@ -10663,14 +10632,16 @@
                 <a:ea typeface="Noto Sans TC"/>
                 <a:cs typeface="Noto Sans TC"/>
               </a:rPr>
-              <a:t>TDD → small reviewable change</a:t>
+              <a:t>Durable｜OpenSpec tasks.md
+/opsx:apply → Superpowers TDD
+一本 ledger、可 review</a:t>
             </a:r>
           </a:p>
         </p:txBody>
       </p:sp>
       <p:cxnSp>
         <p:nvCxnSpPr>
-          <p:cNvPr id="520" name=""/>
+          <p:cNvPr id="670" name=""/>
           <p:cNvCxnSpPr/>
           <p:nvPr/>
         </p:nvCxnSpPr>
@@ -11121,7 +11092,7 @@
       </p:sp>
       <p:cxnSp>
         <p:nvCxnSpPr>
-          <p:cNvPr id="528" name=""/>
+          <p:cNvPr id="678" name=""/>
           <p:cNvCxnSpPr/>
           <p:nvPr/>
         </p:nvCxnSpPr>
@@ -11410,7 +11381,7 @@
       </p:sp>
       <p:cxnSp>
         <p:nvCxnSpPr>
-          <p:cNvPr id="219" name=""/>
+          <p:cNvPr id="237" name=""/>
           <p:cNvCxnSpPr/>
           <p:nvPr/>
         </p:nvCxnSpPr>
@@ -12672,21 +12643,21 @@
                 <a:ea typeface="Noto Sans TC"/>
                 <a:cs typeface="Noto Sans TC"/>
               </a:rPr>
-              <a:t>Illustrative target allocation：stages may overlap；需以既有 10+ pilots actual baseline 持續校準。</a:t>
+              <a:t>Human judgment × AI execution 才是 productivity leverage；8 → 6 weeks 僅為 illustrative target，仍以 pilots 校準。</a:t>
             </a:r>
           </a:p>
         </p:txBody>
       </p:sp>
       <p:pic>
         <p:nvPicPr>
-          <p:cNvPr id="241" name=""/>
+          <p:cNvPr id="259" name=""/>
           <p:cNvPicPr>
             <a:picLocks xmlns:a="http://schemas.openxmlformats.org/drawingml/2006/main" noChangeAspect="1"/>
           </p:cNvPicPr>
           <p:nvPr/>
         </p:nvPicPr>
         <p:blipFill>
-          <a:blip xmlns:r="http://schemas.openxmlformats.org/officeDocument/2006/relationships" xmlns:a="http://schemas.openxmlformats.org/drawingml/2006/main" r:embed="R1c68474ba2764ce6"/>
+          <a:blip xmlns:r="http://schemas.openxmlformats.org/officeDocument/2006/relationships" xmlns:a="http://schemas.openxmlformats.org/drawingml/2006/main" r:embed="R1d13407c32f94a9e"/>
           <a:srcRect xmlns:a="http://schemas.openxmlformats.org/drawingml/2006/main" l="125" t="0" r="125" b="0"/>
           <a:stretch xmlns:a="http://schemas.openxmlformats.org/drawingml/2006/main">
             <a:fillRect l="0" t="0" r="0" b="0"/>
@@ -12851,7 +12822,7 @@
       </p:sp>
       <p:cxnSp>
         <p:nvCxnSpPr>
-          <p:cNvPr id="419" name=""/>
+          <p:cNvPr id="539" name=""/>
           <p:cNvCxnSpPr/>
           <p:nvPr/>
         </p:nvCxnSpPr>
@@ -13109,7 +13080,7 @@
       </p:sp>
       <p:cxnSp>
         <p:nvCxnSpPr>
-          <p:cNvPr id="424" name=""/>
+          <p:cNvPr id="544" name=""/>
           <p:cNvCxnSpPr/>
           <p:nvPr/>
         </p:nvCxnSpPr>
@@ -13249,7 +13220,7 @@
       </p:sp>
       <p:cxnSp>
         <p:nvCxnSpPr>
-          <p:cNvPr id="427" name=""/>
+          <p:cNvPr id="547" name=""/>
           <p:cNvCxnSpPr/>
           <p:nvPr/>
         </p:nvCxnSpPr>
@@ -13389,7 +13360,7 @@
       </p:sp>
       <p:cxnSp>
         <p:nvCxnSpPr>
-          <p:cNvPr id="430" name=""/>
+          <p:cNvPr id="550" name=""/>
           <p:cNvCxnSpPr/>
           <p:nvPr/>
         </p:nvCxnSpPr>
@@ -13529,7 +13500,7 @@
       </p:sp>
       <p:cxnSp>
         <p:nvCxnSpPr>
-          <p:cNvPr id="433" name=""/>
+          <p:cNvPr id="553" name=""/>
           <p:cNvCxnSpPr/>
           <p:nvPr/>
         </p:nvCxnSpPr>
@@ -13669,7 +13640,7 @@
       </p:sp>
       <p:cxnSp>
         <p:nvCxnSpPr>
-          <p:cNvPr id="436" name=""/>
+          <p:cNvPr id="556" name=""/>
           <p:cNvCxnSpPr/>
           <p:nvPr/>
         </p:nvCxnSpPr>
@@ -14422,7 +14393,7 @@
                 <a:ea typeface="Noto Sans TC"/>
                 <a:cs typeface="Noto Sans TC"/>
               </a:rPr>
-              <a:t>開始新工作六題全答；執行中更新 Stage／Next Move；context 改變時六題重答。</a:t>
+              <a:t>AI 執行更多；Engineer 仍負責六題、design trade-off、evidence 與 approval。執行中更新 Stage／Next Move。</a:t>
             </a:r>
           </a:p>
         </p:txBody>

</xml_diff>